<commit_message>
BIH 2026 deck: static-charge fusion, published values, new results and live site
Solution and architecture now include the static channel and accelerometer; prototype slide
shows a shoulder grab caught through the static channel (71 % of grabs over 7 body places,
1 unwanted prompt in 9 h); risks updated to unmeasured body voltages; links to the live site.
</commit_message>
<xml_diff>
--- a/docs/SparshaGuard_BIH2026.pptx
+++ b/docs/SparshaGuard_BIH2026.pptx
@@ -5234,7 +5234,7 @@
                 </a:solidFill>
                 <a:latin typeface="Aptos"/>
               </a:rPr>
-              <a:t>A smartwatch that senses touch. In Guard Mode, another person's hand held at the watch for 2 s starts a 15 s PIN countdown. No PIN or a wrong PIN sends SMS + GPS, calls 112 and records audio.</a:t>
+              <a:t>A smartwatch that feels another person's touch. In Guard Mode, a stranger's grab at the wrist, or anywhere on her body when he pulls her, starts a 15 s PIN countdown. No PIN sends SMS + GPS, calls 112 and records audio.</a:t>
             </a:r>
           </a:p>
         </p:txBody>
@@ -5396,7 +5396,7 @@
                 </a:solidFill>
                 <a:latin typeface="Aptos"/>
               </a:rPr>
-              <a:t>The default is flipped: the touch itself raises the alarm. A duress PIN fakes a cancel and alerts silently; pulling the watch off alerts at once.</a:t>
+              <a:t>Two bodies share static charge the instant they touch. The watch feels that jump, so her own hand, a metal pole or a phone never count as a person.</a:t>
             </a:r>
           </a:p>
         </p:txBody>
@@ -5917,7 +5917,7 @@
                 </a:solidFill>
                 <a:latin typeface="Aptos"/>
               </a:rPr>
-              <a:t>Physics from 15 papers, checked with SPICE + FastCap</a:t>
+              <a:t>Physics from 58 sources, checked with SPICE + FastCap</a:t>
             </a:r>
           </a:p>
         </p:txBody>
@@ -6445,7 +6445,7 @@
                 </a:solidFill>
                 <a:latin typeface="Aptos"/>
               </a:rPr>
-              <a:t>Skin electrode sweep</a:t>
+              <a:t>Sweep + body static + motion</a:t>
             </a:r>
           </a:p>
         </p:txBody>
@@ -6596,7 +6596,7 @@
                 </a:solidFill>
                 <a:latin typeface="Aptos"/>
               </a:rPr>
-              <a:t>Change held for 2 s</a:t>
+              <a:t>Another body, held or pulling</a:t>
             </a:r>
           </a:p>
         </p:txBody>
@@ -7069,7 +7069,7 @@
                 </a:solidFill>
                 <a:latin typeface="Aptos"/>
               </a:rPr>
-              <a:t>Touché swept-frequency, ESP32 + LC tank</a:t>
+              <a:t>Touché sweep + static channel, ESP32, ADS1115, accelerometer</a:t>
             </a:r>
           </a:p>
           <a:p>
@@ -7291,7 +7291,7 @@
                 </a:solidFill>
                 <a:latin typeface="Aptos"/>
               </a:rPr>
-              <a:t>Low-cost parts, battery-powered, every decision on the watch. Each model value is traced to a published paper, and two independent solvers confirm the physics.</a:t>
+              <a:t>Low-cost parts, battery-powered, every decision on the watch. Each value is traced to a published source (58 logged), and two independent solvers confirm the physics.</a:t>
             </a:r>
           </a:p>
         </p:txBody>
@@ -7846,7 +7846,7 @@
                 </a:solidFill>
                 <a:latin typeface="Aptos"/>
               </a:rPr>
-              <a:t>The watch's own firmware runs on a simulated sensor: 200-frequency sweeps, 5 per second, with sweat drift and ADC noise.</a:t>
+              <a:t>The watch's own firmware runs on a simulated sensor: frequency sweeps, body static at 500 Hz and an accelerometer, with drift and noise.</a:t>
             </a:r>
           </a:p>
           <a:p>
@@ -7862,7 +7862,7 @@
                 </a:solidFill>
                 <a:latin typeface="Aptos"/>
               </a:rPr>
-              <a:t>Guided story and a try-it-yourself mode: grab, PIN, duress, strap removal.</a:t>
+              <a:t>Guided story and try-it mode: grabs anywhere, PIN, duress, strap removal.</a:t>
             </a:r>
           </a:p>
         </p:txBody>
@@ -8040,7 +8040,7 @@
                 </a:solidFill>
                 <a:latin typeface="Aptos"/>
               </a:rPr>
-              <a:t>Built from 15 published papers. Python solver matches SPICE to 0.0001 %; 3D field matches MIT FastCap within 1 %.</a:t>
+              <a:t>Values from 58 published sources. Solver matches SPICE to 0.0001 %; 3D field matches MIT FastCap within 1 %.</a:t>
             </a:r>
           </a:p>
           <a:p>
@@ -8056,7 +8056,7 @@
                 </a:solidFill>
                 <a:latin typeface="Aptos"/>
               </a:rPr>
-              <a:t>Wrist grab: ~16 % signal vs 0.1 % noise. 93 % caught in simulated daily life.</a:t>
+              <a:t>71 % of grabs caught over 7 body places (13 % before); 1 unwanted PIN prompt in 9 h.</a:t>
             </a:r>
           </a:p>
         </p:txBody>
@@ -8144,7 +8144,7 @@
       </p:sp>
       <p:pic xmlns:p="http://schemas.openxmlformats.org/presentationml/2006/main" xmlns:a="http://schemas.openxmlformats.org/drawingml/2006/main" xmlns:r="http://schemas.openxmlformats.org/officeDocument/2006/relationships">
         <p:nvPicPr>
-          <p:cNvPr id="90" name="Demo screenshot" descr="SparshaGuard digital-twin demo: watch showing Alert sent, ring red, sensor signal jumped above the 0.3 % threshold"/>
+          <p:cNvPr id="90" name="Demo screenshot" descr="SparshaGuard digital-twin demo: a shoulder grab. The sweep stays near 0.1 %, but the static voltage on her body jumps when another body touches her, arm jerks follow, and the watch asks for the PIN"/>
           <p:cNvPicPr>
             <a:picLocks noChangeAspect="1"/>
           </p:cNvPicPr>
@@ -8158,8 +8158,8 @@
         </p:blipFill>
         <p:spPr>
           <a:xfrm>
-            <a:off x="8229600" y="2395728"/>
-            <a:ext cx="3154680" cy="2306401"/>
+            <a:off x="8503919" y="2331720"/>
+            <a:ext cx="2606040" cy="2352254"/>
           </a:xfrm>
           <a:prstGeom prst="rect">
             <a:avLst/>
@@ -8201,7 +8201,7 @@
                 </a:solidFill>
                 <a:latin typeface="Aptos"/>
               </a:rPr>
-              <a:t xml:space="preserve">Live demo: </a:t>
+              <a:t xml:space="preserve">Live demo + explorer: </a:t>
             </a:r>
             <a:r>
               <a:rPr sz="1400" b="0">
@@ -8210,7 +8210,7 @@
                 </a:solidFill>
                 <a:latin typeface="Aptos"/>
               </a:rPr>
-              <a:t>bhajanth13.github.io/SparshaGuard/demo/sparshaguard_demo.html</a:t>
+              <a:t>bhajanth13.github.io/SparshaGuard</a:t>
             </a:r>
             <a:r>
               <a:rPr sz="1400" b="1">
@@ -8767,7 +8767,7 @@
                 </a:solidFill>
                 <a:latin typeface="Aptos"/>
               </a:rPr>
-              <a:t>Off-the-shelf parts: ESP32, LC tank, steel electrode. Detection logic is already written and tested.</a:t>
+              <a:t>Off-the-shelf parts: ESP32, LC tank, steel electrode, ADS1115, accelerometer. Detection logic is written and tested.</a:t>
             </a:r>
           </a:p>
         </p:txBody>
@@ -9253,7 +9253,7 @@
                 </a:solidFill>
                 <a:latin typeface="Aptos"/>
               </a:rPr>
-              <a:t>The values are simulated, not yet measured. The wrist sensor can't feel grabs on the forearm or shoulder, and ~4–5 unwanted PIN prompts per hour are expected.</a:t>
+              <a:t>Simulated, not yet measured. Static charge on Indian floors is unknown; if both bodies sit at the same voltage, or a grab only holds, it can be missed.</a:t>
             </a:r>
           </a:p>
         </p:txBody>
@@ -9415,7 +9415,7 @@
                 </a:solidFill>
                 <a:latin typeface="Aptos"/>
               </a:rPr>
-              <a:t>A battery prototype (Gate 1) measures the remaining values. Motion and on-device audio sensing cover grabs away from the wrist; the PIN handles friendly touches.</a:t>
+              <a:t>A battery prototype (Gate 1) measures body voltages and grab motion. The wrist sweep still catches wrist grabs; the PIN handles friendly touches.</a:t>
             </a:r>
           </a:p>
         </p:txBody>
@@ -10278,7 +10278,7 @@
                 </a:solidFill>
                 <a:latin typeface="Aptos"/>
               </a:rPr>
-              <a:t>≥ 90 % of wrist grabs caught on hardware · &lt; 2 unwanted prompts per hour · alert sent within 20 s</a:t>
+              <a:t>≥ 90 % of wrist grabs and ≥ 60 % anywhere on hardware · &lt; 1 unwanted prompt a day · alert within 20 s</a:t>
             </a:r>
           </a:p>
         </p:txBody>
@@ -10661,7 +10661,7 @@
                 </a:solidFill>
                 <a:latin typeface="Aptos"/>
               </a:rPr>
-              <a:t>Motion + audio, college pilot</a:t>
+              <a:t>Audio confirm, college pilot</a:t>
             </a:r>
           </a:p>
         </p:txBody>
@@ -11676,7 +11676,7 @@
                 </a:solidFill>
                 <a:latin typeface="Aptos"/>
               </a:rPr>
-              <a:t>Proposal → sourced physics model → SPICE and FastCap checks → digital twin → Gate 1 prototype</a:t>
+              <a:t>Proposal → sourced physics → SPICE and FastCap checks → digital twin → static-charge fusion → Gate 1 prototype</a:t>
             </a:r>
           </a:p>
         </p:txBody>
@@ -11972,7 +11972,19 @@
                 </a:solidFill>
                 <a:latin typeface="Aptos"/>
               </a:rPr>
-              <a:t>github.com/Bhajanth13/SparshaGuard   |   Live demo on GitHub Pages</a:t>
+              <a:t>Live: bhajanth13.github.io/SparshaGuard</a:t>
+            </a:r>
+          </a:p>
+          <a:p>
+            <a:pPr algn="ctr"/>
+            <a:r>
+              <a:rPr sz="1300" b="1">
+                <a:solidFill>
+                  <a:srgbClr val="191B5C"/>
+                </a:solidFill>
+                <a:latin typeface="Aptos"/>
+              </a:rPr>
+              <a:t>Code: github.com/Bhajanth13/SparshaGuard</a:t>
             </a:r>
           </a:p>
         </p:txBody>

</xml_diff>

<commit_message>
Signs of assault: final check numbers, struggle right after running, deck and front page
Struggle check now pauses only while the 4 s window still holds running, so a struggle right
after she runs is caught (92 %) without false prompts at the end of a run (0 of 150).
Headless check: 99 % of struggles caught with no touch, 99 % of touches while running, running
alone prompted 1.7 % of runs, 0 unwanted prompts in 9 h (sweep only 28), body coverage 70 %.
Deck: mic at the PIN prompt, voice + GPS in the alert, motion and heart-rate sensors, results.
</commit_message>
<xml_diff>
--- a/docs/SparshaGuard_BIH2026.pptx
+++ b/docs/SparshaGuard_BIH2026.pptx
@@ -5234,7 +5234,7 @@
                 </a:solidFill>
                 <a:latin typeface="Aptos"/>
               </a:rPr>
-              <a:t>A smartwatch that feels another person's touch. In Guard Mode, a stranger's grab at the wrist, or anywhere on her body when he pulls her, starts a 15 s PIN countdown. No PIN sends SMS + GPS, calls 112 and records audio.</a:t>
+              <a:t>A smartwatch that feels another person's touch. In Guard Mode, a stranger's grab, or her struggling to get free, starts a 15 s PIN countdown and turns the mic on. No PIN sends SMS, GPS and the voice recording, and calls 112.</a:t>
             </a:r>
           </a:p>
         </p:txBody>
@@ -6445,7 +6445,7 @@
                 </a:solidFill>
                 <a:latin typeface="Aptos"/>
               </a:rPr>
-              <a:t>Sweep + body static + motion</a:t>
+              <a:t>Touch, static, motion, heart rate</a:t>
             </a:r>
           </a:p>
         </p:txBody>
@@ -6596,7 +6596,7 @@
                 </a:solidFill>
                 <a:latin typeface="Aptos"/>
               </a:rPr>
-              <a:t>Another body, held or pulling</a:t>
+              <a:t>Another body, pulling or struggle</a:t>
             </a:r>
           </a:p>
         </p:txBody>
@@ -6898,7 +6898,7 @@
                 </a:solidFill>
                 <a:latin typeface="Aptos"/>
               </a:rPr>
-              <a:t>SMS + GPS · call 112 · audio</a:t>
+              <a:t>SMS · GPS · voice · 112</a:t>
             </a:r>
           </a:p>
         </p:txBody>
@@ -7069,7 +7069,7 @@
                 </a:solidFill>
                 <a:latin typeface="Aptos"/>
               </a:rPr>
-              <a:t>Touché sweep + static channel, ESP32, ADS1115, accelerometer</a:t>
+              <a:t>Touché sweep, static channel, accelerometer, gyroscope, heart rate, mic</a:t>
             </a:r>
           </a:p>
           <a:p>
@@ -7846,7 +7846,7 @@
                 </a:solidFill>
                 <a:latin typeface="Aptos"/>
               </a:rPr>
-              <a:t>The watch's own firmware runs on a simulated sensor: frequency sweeps, body static at 500 Hz and an accelerometer, with drift and noise.</a:t>
+              <a:t>The watch's own firmware runs on a simulated sensor: frequency sweeps, body static at 500 Hz, accelerometer, gyroscope and heart rate.</a:t>
             </a:r>
           </a:p>
           <a:p>
@@ -7862,7 +7862,7 @@
                 </a:solidFill>
                 <a:latin typeface="Aptos"/>
               </a:rPr>
-              <a:t>Guided story and try-it mode: grabs anywhere, PIN, duress, strap removal.</a:t>
+              <a:t>Guided story and try-it mode: grabs, struggle, running, PIN, duress, strap removal.</a:t>
             </a:r>
           </a:p>
         </p:txBody>
@@ -8056,7 +8056,7 @@
                 </a:solidFill>
                 <a:latin typeface="Aptos"/>
               </a:rPr>
-              <a:t>71 % of grabs caught over 7 body places (13 % before); 1 unwanted PIN prompt in 9 h.</a:t>
+              <a:t>70 % of grabs over 7 body places (13 % before), 99 % of struggles; 0–1 unwanted prompts in 9 h.</a:t>
             </a:r>
           </a:p>
         </p:txBody>
@@ -8767,7 +8767,7 @@
                 </a:solidFill>
                 <a:latin typeface="Aptos"/>
               </a:rPr>
-              <a:t>Off-the-shelf parts: ESP32, LC tank, steel electrode, ADS1115, accelerometer. Detection logic is written and tested.</a:t>
+              <a:t>Off-the-shelf parts: ESP32, LC tank, electrode, ADS1115, motion sensor, heart-rate sensor, mic. Detection logic is written and tested.</a:t>
             </a:r>
           </a:p>
         </p:txBody>
@@ -9253,7 +9253,7 @@
                 </a:solidFill>
                 <a:latin typeface="Aptos"/>
               </a:rPr>
-              <a:t>Simulated, not yet measured. Static charge on Indian floors is unknown; if both bodies sit at the same voltage, or a grab only holds, it can be missed.</a:t>
+              <a:t>Simulated, not yet measured. Static charge on Indian floors and struggle-motion thresholds are estimates; a grab that only holds can be missed.</a:t>
             </a:r>
           </a:p>
         </p:txBody>
@@ -9415,7 +9415,7 @@
                 </a:solidFill>
                 <a:latin typeface="Aptos"/>
               </a:rPr>
-              <a:t>A battery prototype (Gate 1) measures body voltages and grab motion. The wrist sweep still catches wrist grabs; the PIN handles friendly touches.</a:t>
+              <a:t>A battery prototype (Gate 1) measures body voltages and staged-struggle motion. The wrist sweep still catches wrist grabs; the PIN handles friendly touches.</a:t>
             </a:r>
           </a:p>
         </p:txBody>

</xml_diff>

<commit_message>
Deck: RV University, Mysuru
</commit_message>
<xml_diff>
--- a/docs/SparshaGuard_BIH2026.pptx
+++ b/docs/SparshaGuard_BIH2026.pptx
@@ -3565,7 +3565,7 @@
                 </a:solidFill>
                 <a:latin typeface="Aptos"/>
               </a:rPr>
-              <a:t>RV University, Bengaluru</a:t>
+              <a:t>RV University, Mysuru</a:t>
             </a:r>
           </a:p>
         </p:txBody>
@@ -11514,7 +11514,7 @@
                 </a:solidFill>
                 <a:latin typeface="Aptos"/>
               </a:rPr>
-              <a:t>RV University, Bengaluru</a:t>
+              <a:t>RV University, Mysuru</a:t>
             </a:r>
           </a:p>
         </p:txBody>

</xml_diff>

<commit_message>
Source count 60 in explorer, README and deck
</commit_message>
<xml_diff>
--- a/docs/SparshaGuard_BIH2026.pptx
+++ b/docs/SparshaGuard_BIH2026.pptx
@@ -5917,7 +5917,7 @@
                 </a:solidFill>
                 <a:latin typeface="Aptos"/>
               </a:rPr>
-              <a:t>Physics from 58 sources, checked with SPICE + FastCap</a:t>
+              <a:t>Physics from 60 sources, checked with SPICE + FastCap</a:t>
             </a:r>
           </a:p>
         </p:txBody>
@@ -7291,7 +7291,7 @@
                 </a:solidFill>
                 <a:latin typeface="Aptos"/>
               </a:rPr>
-              <a:t>Low-cost parts, battery-powered, every decision on the watch. Each value is traced to a published source (58 logged), and two independent solvers confirm the physics.</a:t>
+              <a:t>Low-cost parts, battery-powered, every decision on the watch. Each value is traced to a published source (60 logged), and two independent solvers confirm the physics.</a:t>
             </a:r>
           </a:p>
         </p:txBody>
@@ -8040,7 +8040,7 @@
                 </a:solidFill>
                 <a:latin typeface="Aptos"/>
               </a:rPr>
-              <a:t>Values from 58 published sources. Solver matches SPICE to 0.0001 %; 3D field matches MIT FastCap within 1 %.</a:t>
+              <a:t>Values from 60 published sources. Solver matches SPICE to 0.0001 %; 3D field matches MIT FastCap within 1 %.</a:t>
             </a:r>
           </a:p>
           <a:p>

</xml_diff>

<commit_message>
Deck slide 2: a clear problem definition
</commit_message>
<xml_diff>
--- a/docs/SparshaGuard_BIH2026.pptx
+++ b/docs/SparshaGuard_BIH2026.pptx
@@ -4174,7 +4174,7 @@
                 </a:solidFill>
                 <a:latin typeface="Aptos"/>
               </a:rPr>
-              <a:t>The problem</a:t>
+              <a:t>Problem definition</a:t>
             </a:r>
           </a:p>
         </p:txBody>
@@ -4209,7 +4209,7 @@
                 </a:solidFill>
                 <a:latin typeface="Aptos"/>
               </a:rPr>
-              <a:t>In an attack there is rarely time to find a phone, unlock it and press SOS. Almost every safety app needs the victim to act first.</a:t>
+              <a:t>Every personal safety alert today (SOS apps, panic buttons) needs the victim to act first, which an attack rarely allows. No wearable raises an alarm on its own when another person touches her.</a:t>
             </a:r>
           </a:p>
         </p:txBody>

</xml_diff>

<commit_message>
Deck slide 2: problem definition as bullet points
</commit_message>
<xml_diff>
--- a/docs/SparshaGuard_BIH2026.pptx
+++ b/docs/SparshaGuard_BIH2026.pptx
@@ -4201,15 +4201,48 @@
           </a:bodyPr>
           <a:lstStyle/>
           <a:p>
-            <a:pPr algn="l"/>
-            <a:r>
-              <a:rPr sz="1500" b="0">
+            <a:pPr algn="l" marL="228600" indent="-228600">
+              <a:buFont typeface="Arial"/>
+              <a:buChar char="•"/>
+            </a:pPr>
+            <a:r>
+              <a:rPr sz="1400" b="0">
                 <a:solidFill>
                   <a:srgbClr val="2D2B39"/>
                 </a:solidFill>
                 <a:latin typeface="Aptos"/>
               </a:rPr>
-              <a:t>Every personal safety alert today (SOS apps, panic buttons) needs the victim to act first, which an attack rarely allows. No wearable raises an alarm on its own when another person touches her.</a:t>
+              <a:t>Every personal safety alert today (SOS apps, panic buttons) needs the victim to act first.</a:t>
+            </a:r>
+          </a:p>
+          <a:p>
+            <a:pPr algn="l" marL="228600" indent="-228600">
+              <a:buFont typeface="Arial"/>
+              <a:buChar char="•"/>
+            </a:pPr>
+            <a:r>
+              <a:rPr sz="1400" b="0">
+                <a:solidFill>
+                  <a:srgbClr val="2D2B39"/>
+                </a:solidFill>
+                <a:latin typeface="Aptos"/>
+              </a:rPr>
+              <a:t>An attack rarely allows that.</a:t>
+            </a:r>
+          </a:p>
+          <a:p>
+            <a:pPr algn="l" marL="228600" indent="-228600">
+              <a:buFont typeface="Arial"/>
+              <a:buChar char="•"/>
+            </a:pPr>
+            <a:r>
+              <a:rPr sz="1400" b="0">
+                <a:solidFill>
+                  <a:srgbClr val="2D2B39"/>
+                </a:solidFill>
+                <a:latin typeface="Aptos"/>
+              </a:rPr>
+              <a:t>No wearable raises an alarm on its own when another person touches her.</a:t>
             </a:r>
           </a:p>
         </p:txBody>

</xml_diff>

<commit_message>
Deck slide 2: bullet points for who is affected and current limitations; NCRB evidence as a graphic
</commit_message>
<xml_diff>
--- a/docs/SparshaGuard_BIH2026.pptx
+++ b/docs/SparshaGuard_BIH2026.pptx
@@ -4396,15 +4396,63 @@
           </a:bodyPr>
           <a:lstStyle/>
           <a:p>
-            <a:pPr algn="l"/>
-            <a:r>
-              <a:rPr sz="1500" b="0">
+            <a:pPr algn="l" marL="228600" indent="-228600">
+              <a:buFont typeface="Arial"/>
+              <a:buChar char="•"/>
+            </a:pPr>
+            <a:r>
+              <a:rPr sz="1400" b="0">
                 <a:solidFill>
                   <a:srgbClr val="2D2B39"/>
                 </a:solidFill>
                 <a:latin typeface="Aptos"/>
               </a:rPr>
-              <a:t>Women walking alone at night, commuting in crowded buses and metros, or riding cabs and autos, and the families waiting for them.</a:t>
+              <a:t>Women walking alone at night</a:t>
+            </a:r>
+          </a:p>
+          <a:p>
+            <a:pPr algn="l" marL="228600" indent="-228600">
+              <a:buFont typeface="Arial"/>
+              <a:buChar char="•"/>
+            </a:pPr>
+            <a:r>
+              <a:rPr sz="1400" b="0">
+                <a:solidFill>
+                  <a:srgbClr val="2D2B39"/>
+                </a:solidFill>
+                <a:latin typeface="Aptos"/>
+              </a:rPr>
+              <a:t>Commuters in crowded buses and metros</a:t>
+            </a:r>
+          </a:p>
+          <a:p>
+            <a:pPr algn="l" marL="228600" indent="-228600">
+              <a:buFont typeface="Arial"/>
+              <a:buChar char="•"/>
+            </a:pPr>
+            <a:r>
+              <a:rPr sz="1400" b="0">
+                <a:solidFill>
+                  <a:srgbClr val="2D2B39"/>
+                </a:solidFill>
+                <a:latin typeface="Aptos"/>
+              </a:rPr>
+              <a:t>Women riding cabs and autos</a:t>
+            </a:r>
+          </a:p>
+          <a:p>
+            <a:pPr algn="l" marL="228600" indent="-228600">
+              <a:buFont typeface="Arial"/>
+              <a:buChar char="•"/>
+            </a:pPr>
+            <a:r>
+              <a:rPr sz="1400" b="0">
+                <a:solidFill>
+                  <a:srgbClr val="2D2B39"/>
+                </a:solidFill>
+                <a:latin typeface="Aptos"/>
+              </a:rPr>
+              <a:t>The families waiting for them</a:t>
             </a:r>
           </a:p>
         </p:txBody>
@@ -4418,7 +4466,7 @@
         <p:spPr>
           <a:xfrm>
             <a:off x="640080" y="3703320"/>
-            <a:ext cx="5349240" cy="1691640"/>
+            <a:ext cx="5349240" cy="2240280"/>
           </a:xfrm>
           <a:prstGeom prst="roundRect">
             <a:avLst/>
@@ -4464,7 +4512,7 @@
         <p:spPr>
           <a:xfrm>
             <a:off x="640080" y="3703320"/>
-            <a:ext cx="68580" cy="1691640"/>
+            <a:ext cx="68580" cy="2240280"/>
           </a:xfrm>
           <a:prstGeom prst="rect">
             <a:avLst/>
@@ -4545,7 +4593,7 @@
         <p:spPr>
           <a:xfrm>
             <a:off x="822959" y="4178808"/>
-            <a:ext cx="5029200" cy="1124712"/>
+            <a:ext cx="5029200" cy="1600000"/>
           </a:xfrm>
           <a:prstGeom prst="rect">
             <a:avLst/>
@@ -4558,15 +4606,33 @@
           </a:bodyPr>
           <a:lstStyle/>
           <a:p>
-            <a:pPr algn="l"/>
-            <a:r>
-              <a:rPr sz="1500" b="0">
+            <a:pPr algn="l" marL="228600" indent="-228600">
+              <a:buFont typeface="Arial"/>
+              <a:buChar char="•"/>
+            </a:pPr>
+            <a:r>
+              <a:rPr sz="1400" b="0">
                 <a:solidFill>
                   <a:srgbClr val="2D2B39"/>
                 </a:solidFill>
                 <a:latin typeface="Aptos"/>
               </a:rPr>
-              <a:t>SOS apps and panic buttons need a deliberate action. Fall and heart-rate alerts on wearables can't tell a stranger's grab from daily movement.</a:t>
+              <a:t>SOS apps and panic buttons need a deliberate action</a:t>
+            </a:r>
+          </a:p>
+          <a:p>
+            <a:pPr algn="l" marL="228600" indent="-228600">
+              <a:buFont typeface="Arial"/>
+              <a:buChar char="•"/>
+            </a:pPr>
+            <a:r>
+              <a:rPr sz="1400" b="0">
+                <a:solidFill>
+                  <a:srgbClr val="2D2B39"/>
+                </a:solidFill>
+                <a:latin typeface="Aptos"/>
+              </a:rPr>
+              <a:t>Fall and heart-rate alerts on wearables can't tell a stranger's grab from daily movement</a:t>
             </a:r>
           </a:p>
         </p:txBody>
@@ -4580,7 +4646,7 @@
         <p:spPr>
           <a:xfrm>
             <a:off x="6217920" y="3703320"/>
-            <a:ext cx="5349240" cy="1691640"/>
+            <a:ext cx="5349240" cy="2240280"/>
           </a:xfrm>
           <a:prstGeom prst="roundRect">
             <a:avLst/>
@@ -4626,7 +4692,7 @@
         <p:spPr>
           <a:xfrm>
             <a:off x="6217920" y="3703320"/>
-            <a:ext cx="68580" cy="1691640"/>
+            <a:ext cx="68580" cy="2240280"/>
           </a:xfrm>
           <a:prstGeom prst="rect">
             <a:avLst/>
@@ -4694,41 +4760,6 @@
                 <a:latin typeface="Aptos"/>
               </a:rPr>
               <a:t>Evidence</a:t>
-            </a:r>
-          </a:p>
-        </p:txBody>
-      </p:sp>
-      <p:sp>
-        <p:nvSpPr>
-          <p:cNvPr id="26" name="TextBox 25"/>
-          <p:cNvSpPr txBox="1"/>
-          <p:nvPr/>
-        </p:nvSpPr>
-        <p:spPr>
-          <a:xfrm>
-            <a:off x="6400800" y="4178808"/>
-            <a:ext cx="5029200" cy="1124712"/>
-          </a:xfrm>
-          <a:prstGeom prst="rect">
-            <a:avLst/>
-          </a:prstGeom>
-          <a:noFill/>
-        </p:spPr>
-        <p:txBody>
-          <a:bodyPr wrap="square" lIns="54864" tIns="18288" rIns="54864" bIns="18288" anchor="t">
-            <a:spAutoFit/>
-          </a:bodyPr>
-          <a:lstStyle/>
-          <a:p>
-            <a:pPr algn="l"/>
-            <a:r>
-              <a:rPr sz="1500" b="0">
-                <a:solidFill>
-                  <a:srgbClr val="2D2B39"/>
-                </a:solidFill>
-                <a:latin typeface="Aptos"/>
-              </a:rPr>
-              <a:t>NCRB, Crime in India 2022: 4,45,256 crimes against women registered, up 4 % on 2021; 18.7 % were assaults on a woman's modesty.</a:t>
             </a:r>
           </a:p>
         </p:txBody>
@@ -4764,6 +4795,532 @@
           </a:prstGeom>
         </p:spPr>
       </p:pic>
+      <p:sp>
+        <p:nvSpPr>
+          <p:cNvPr id="29" name="TextBox 28"/>
+          <p:cNvSpPr txBox="1"/>
+          <p:nvPr/>
+        </p:nvSpPr>
+        <p:spPr>
+          <a:xfrm>
+            <a:off x="6400800" y="4160000"/>
+            <a:ext cx="2560000" cy="260000"/>
+          </a:xfrm>
+          <a:prstGeom prst="rect">
+            <a:avLst/>
+          </a:prstGeom>
+          <a:noFill/>
+        </p:spPr>
+        <p:txBody>
+          <a:bodyPr wrap="square" lIns="0" rIns="0" tIns="0" bIns="0" anchor="t">
+            <a:spAutoFit/>
+          </a:bodyPr>
+          <a:lstStyle/>
+          <a:p>
+            <a:pPr algn="l"/>
+            <a:r>
+              <a:rPr sz="1200" b="1">
+                <a:solidFill>
+                  <a:srgbClr val="2D2B39"/>
+                </a:solidFill>
+                <a:latin typeface="Aptos"/>
+              </a:rPr>
+              <a:t>Crimes against women registered</a:t>
+            </a:r>
+          </a:p>
+        </p:txBody>
+      </p:sp>
+      <p:sp>
+        <p:nvSpPr>
+          <p:cNvPr id="30" name="TextBox 29"/>
+          <p:cNvSpPr txBox="1"/>
+          <p:nvPr/>
+        </p:nvSpPr>
+        <p:spPr>
+          <a:xfrm>
+            <a:off x="6400800" y="4540000"/>
+            <a:ext cx="420000" cy="230000"/>
+          </a:xfrm>
+          <a:prstGeom prst="rect">
+            <a:avLst/>
+          </a:prstGeom>
+          <a:noFill/>
+        </p:spPr>
+        <p:txBody>
+          <a:bodyPr wrap="square" lIns="0" rIns="0" tIns="0" bIns="0" anchor="ctr">
+            <a:spAutoFit/>
+          </a:bodyPr>
+          <a:lstStyle/>
+          <a:p>
+            <a:pPr algn="l"/>
+            <a:r>
+              <a:rPr sz="1100" b="0">
+                <a:solidFill>
+                  <a:srgbClr val="6B6A78"/>
+                </a:solidFill>
+                <a:latin typeface="Aptos"/>
+              </a:rPr>
+              <a:t>2021</a:t>
+            </a:r>
+          </a:p>
+        </p:txBody>
+      </p:sp>
+      <p:sp>
+        <p:nvSpPr>
+          <p:cNvPr id="31" name="Rectangle 30"/>
+          <p:cNvSpPr/>
+          <p:nvPr/>
+        </p:nvSpPr>
+        <p:spPr>
+          <a:xfrm>
+            <a:off x="6820800" y="4540000"/>
+            <a:ext cx="1442803" cy="230000"/>
+          </a:xfrm>
+          <a:prstGeom prst="rect">
+            <a:avLst/>
+          </a:prstGeom>
+          <a:solidFill>
+            <a:srgbClr val="9A9CC4"/>
+          </a:solidFill>
+          <a:ln>
+            <a:noFill/>
+          </a:ln>
+          <a:effectLst/>
+        </p:spPr>
+        <p:style>
+          <a:lnRef idx="1">
+            <a:schemeClr val="accent1"/>
+          </a:lnRef>
+          <a:fillRef idx="3">
+            <a:schemeClr val="accent1"/>
+          </a:fillRef>
+          <a:effectRef idx="2">
+            <a:schemeClr val="accent1"/>
+          </a:effectRef>
+          <a:fontRef idx="minor">
+            <a:schemeClr val="lt1"/>
+          </a:fontRef>
+        </p:style>
+        <p:txBody>
+          <a:bodyPr rtlCol="0" anchor="ctr"/>
+          <a:lstStyle/>
+          <a:p>
+            <a:pPr algn="ctr"/>
+          </a:p>
+        </p:txBody>
+      </p:sp>
+      <p:sp>
+        <p:nvSpPr>
+          <p:cNvPr id="32" name="TextBox 31"/>
+          <p:cNvSpPr txBox="1"/>
+          <p:nvPr/>
+        </p:nvSpPr>
+        <p:spPr>
+          <a:xfrm>
+            <a:off x="8333603" y="4540000"/>
+            <a:ext cx="700000" cy="230000"/>
+          </a:xfrm>
+          <a:prstGeom prst="rect">
+            <a:avLst/>
+          </a:prstGeom>
+          <a:noFill/>
+        </p:spPr>
+        <p:txBody>
+          <a:bodyPr wrap="square" lIns="0" rIns="0" tIns="0" bIns="0" anchor="ctr">
+            <a:spAutoFit/>
+          </a:bodyPr>
+          <a:lstStyle/>
+          <a:p>
+            <a:pPr algn="l"/>
+            <a:r>
+              <a:rPr sz="1100" b="1">
+                <a:solidFill>
+                  <a:srgbClr val="2D2B39"/>
+                </a:solidFill>
+                <a:latin typeface="Aptos"/>
+              </a:rPr>
+              <a:t>4,28,278</a:t>
+            </a:r>
+          </a:p>
+        </p:txBody>
+      </p:sp>
+      <p:sp>
+        <p:nvSpPr>
+          <p:cNvPr id="33" name="TextBox 32"/>
+          <p:cNvSpPr txBox="1"/>
+          <p:nvPr/>
+        </p:nvSpPr>
+        <p:spPr>
+          <a:xfrm>
+            <a:off x="6400800" y="4900000"/>
+            <a:ext cx="420000" cy="230000"/>
+          </a:xfrm>
+          <a:prstGeom prst="rect">
+            <a:avLst/>
+          </a:prstGeom>
+          <a:noFill/>
+        </p:spPr>
+        <p:txBody>
+          <a:bodyPr wrap="square" lIns="0" rIns="0" tIns="0" bIns="0" anchor="ctr">
+            <a:spAutoFit/>
+          </a:bodyPr>
+          <a:lstStyle/>
+          <a:p>
+            <a:pPr algn="l"/>
+            <a:r>
+              <a:rPr sz="1100" b="0">
+                <a:solidFill>
+                  <a:srgbClr val="6B6A78"/>
+                </a:solidFill>
+                <a:latin typeface="Aptos"/>
+              </a:rPr>
+              <a:t>2022</a:t>
+            </a:r>
+          </a:p>
+        </p:txBody>
+      </p:sp>
+      <p:sp>
+        <p:nvSpPr>
+          <p:cNvPr id="34" name="Rectangle 33"/>
+          <p:cNvSpPr/>
+          <p:nvPr/>
+        </p:nvSpPr>
+        <p:spPr>
+          <a:xfrm>
+            <a:off x="6820800" y="4900000"/>
+            <a:ext cx="1500000" cy="230000"/>
+          </a:xfrm>
+          <a:prstGeom prst="rect">
+            <a:avLst/>
+          </a:prstGeom>
+          <a:solidFill>
+            <a:srgbClr val="191B5C"/>
+          </a:solidFill>
+          <a:ln>
+            <a:noFill/>
+          </a:ln>
+          <a:effectLst/>
+        </p:spPr>
+        <p:style>
+          <a:lnRef idx="1">
+            <a:schemeClr val="accent1"/>
+          </a:lnRef>
+          <a:fillRef idx="3">
+            <a:schemeClr val="accent1"/>
+          </a:fillRef>
+          <a:effectRef idx="2">
+            <a:schemeClr val="accent1"/>
+          </a:effectRef>
+          <a:fontRef idx="minor">
+            <a:schemeClr val="lt1"/>
+          </a:fontRef>
+        </p:style>
+        <p:txBody>
+          <a:bodyPr rtlCol="0" anchor="ctr"/>
+          <a:lstStyle/>
+          <a:p>
+            <a:pPr algn="ctr"/>
+          </a:p>
+        </p:txBody>
+      </p:sp>
+      <p:sp>
+        <p:nvSpPr>
+          <p:cNvPr id="35" name="TextBox 34"/>
+          <p:cNvSpPr txBox="1"/>
+          <p:nvPr/>
+        </p:nvSpPr>
+        <p:spPr>
+          <a:xfrm>
+            <a:off x="8390800" y="4900000"/>
+            <a:ext cx="700000" cy="230000"/>
+          </a:xfrm>
+          <a:prstGeom prst="rect">
+            <a:avLst/>
+          </a:prstGeom>
+          <a:noFill/>
+        </p:spPr>
+        <p:txBody>
+          <a:bodyPr wrap="square" lIns="0" rIns="0" tIns="0" bIns="0" anchor="ctr">
+            <a:spAutoFit/>
+          </a:bodyPr>
+          <a:lstStyle/>
+          <a:p>
+            <a:pPr algn="l"/>
+            <a:r>
+              <a:rPr sz="1100" b="1">
+                <a:solidFill>
+                  <a:srgbClr val="2D2B39"/>
+                </a:solidFill>
+                <a:latin typeface="Aptos"/>
+              </a:rPr>
+              <a:t>4,45,256</a:t>
+            </a:r>
+          </a:p>
+        </p:txBody>
+      </p:sp>
+      <p:sp>
+        <p:nvSpPr>
+          <p:cNvPr id="36" name="TextBox 35"/>
+          <p:cNvSpPr txBox="1"/>
+          <p:nvPr/>
+        </p:nvSpPr>
+        <p:spPr>
+          <a:xfrm>
+            <a:off x="6400800" y="5290000"/>
+            <a:ext cx="2560000" cy="260000"/>
+          </a:xfrm>
+          <a:prstGeom prst="rect">
+            <a:avLst/>
+          </a:prstGeom>
+          <a:noFill/>
+        </p:spPr>
+        <p:txBody>
+          <a:bodyPr wrap="square" lIns="0" rIns="0" tIns="0" bIns="0" anchor="t">
+            <a:spAutoFit/>
+          </a:bodyPr>
+          <a:lstStyle/>
+          <a:p>
+            <a:pPr algn="l"/>
+            <a:r>
+              <a:rPr sz="1100" b="0">
+                <a:solidFill>
+                  <a:srgbClr val="6B6A78"/>
+                </a:solidFill>
+                <a:latin typeface="Aptos"/>
+              </a:rPr>
+              <a:t>+4 % in one year: about 51 every hour</a:t>
+            </a:r>
+          </a:p>
+        </p:txBody>
+      </p:sp>
+      <p:sp>
+        <p:nvSpPr>
+          <p:cNvPr id="37" name="TextBox 36"/>
+          <p:cNvSpPr txBox="1"/>
+          <p:nvPr/>
+        </p:nvSpPr>
+        <p:spPr>
+          <a:xfrm>
+            <a:off x="9200800" y="4120000"/>
+            <a:ext cx="2229200" cy="480000"/>
+          </a:xfrm>
+          <a:prstGeom prst="rect">
+            <a:avLst/>
+          </a:prstGeom>
+          <a:noFill/>
+        </p:spPr>
+        <p:txBody>
+          <a:bodyPr wrap="square" lIns="0" rIns="0" tIns="0" bIns="0" anchor="t">
+            <a:spAutoFit/>
+          </a:bodyPr>
+          <a:lstStyle/>
+          <a:p>
+            <a:pPr algn="l"/>
+            <a:r>
+              <a:rPr sz="2800" b="1">
+                <a:solidFill>
+                  <a:srgbClr val="5B2278"/>
+                </a:solidFill>
+                <a:latin typeface="Aptos"/>
+              </a:rPr>
+              <a:t>18.7 %</a:t>
+            </a:r>
+          </a:p>
+        </p:txBody>
+      </p:sp>
+      <p:sp>
+        <p:nvSpPr>
+          <p:cNvPr id="38" name="TextBox 37"/>
+          <p:cNvSpPr txBox="1"/>
+          <p:nvPr/>
+        </p:nvSpPr>
+        <p:spPr>
+          <a:xfrm>
+            <a:off x="9200800" y="4600000"/>
+            <a:ext cx="2229200" cy="420000"/>
+          </a:xfrm>
+          <a:prstGeom prst="rect">
+            <a:avLst/>
+          </a:prstGeom>
+          <a:noFill/>
+        </p:spPr>
+        <p:txBody>
+          <a:bodyPr wrap="square" lIns="0" rIns="0" tIns="0" bIns="0" anchor="t">
+            <a:spAutoFit/>
+          </a:bodyPr>
+          <a:lstStyle/>
+          <a:p>
+            <a:pPr algn="l"/>
+            <a:r>
+              <a:rPr sz="1100" b="0">
+                <a:solidFill>
+                  <a:srgbClr val="2D2B39"/>
+                </a:solidFill>
+                <a:latin typeface="Aptos"/>
+              </a:rPr>
+              <a:t>were assaults on a woman's modesty</a:t>
+            </a:r>
+          </a:p>
+        </p:txBody>
+      </p:sp>
+      <p:sp>
+        <p:nvSpPr>
+          <p:cNvPr id="39" name="Rectangle 38"/>
+          <p:cNvSpPr/>
+          <p:nvPr/>
+        </p:nvSpPr>
+        <p:spPr>
+          <a:xfrm>
+            <a:off x="9200800" y="5160000"/>
+            <a:ext cx="2229200" cy="200000"/>
+          </a:xfrm>
+          <a:prstGeom prst="rect">
+            <a:avLst/>
+          </a:prstGeom>
+          <a:solidFill>
+            <a:srgbClr val="E6E6EE"/>
+          </a:solidFill>
+          <a:ln>
+            <a:noFill/>
+          </a:ln>
+          <a:effectLst/>
+        </p:spPr>
+        <p:style>
+          <a:lnRef idx="1">
+            <a:schemeClr val="accent1"/>
+          </a:lnRef>
+          <a:fillRef idx="3">
+            <a:schemeClr val="accent1"/>
+          </a:fillRef>
+          <a:effectRef idx="2">
+            <a:schemeClr val="accent1"/>
+          </a:effectRef>
+          <a:fontRef idx="minor">
+            <a:schemeClr val="lt1"/>
+          </a:fontRef>
+        </p:style>
+        <p:txBody>
+          <a:bodyPr rtlCol="0" anchor="ctr"/>
+          <a:lstStyle/>
+          <a:p>
+            <a:pPr algn="ctr"/>
+          </a:p>
+        </p:txBody>
+      </p:sp>
+      <p:sp>
+        <p:nvSpPr>
+          <p:cNvPr id="40" name="Rectangle 39"/>
+          <p:cNvSpPr/>
+          <p:nvPr/>
+        </p:nvSpPr>
+        <p:spPr>
+          <a:xfrm>
+            <a:off x="9200800" y="5160000"/>
+            <a:ext cx="416860" cy="200000"/>
+          </a:xfrm>
+          <a:prstGeom prst="rect">
+            <a:avLst/>
+          </a:prstGeom>
+          <a:solidFill>
+            <a:srgbClr val="5B2278"/>
+          </a:solidFill>
+          <a:ln>
+            <a:noFill/>
+          </a:ln>
+          <a:effectLst/>
+        </p:spPr>
+        <p:style>
+          <a:lnRef idx="1">
+            <a:schemeClr val="accent1"/>
+          </a:lnRef>
+          <a:fillRef idx="3">
+            <a:schemeClr val="accent1"/>
+          </a:fillRef>
+          <a:effectRef idx="2">
+            <a:schemeClr val="accent1"/>
+          </a:effectRef>
+          <a:fontRef idx="minor">
+            <a:schemeClr val="lt1"/>
+          </a:fontRef>
+        </p:style>
+        <p:txBody>
+          <a:bodyPr rtlCol="0" anchor="ctr"/>
+          <a:lstStyle/>
+          <a:p>
+            <a:pPr algn="ctr"/>
+          </a:p>
+        </p:txBody>
+      </p:sp>
+      <p:sp>
+        <p:nvSpPr>
+          <p:cNvPr id="41" name="TextBox 40"/>
+          <p:cNvSpPr txBox="1"/>
+          <p:nvPr/>
+        </p:nvSpPr>
+        <p:spPr>
+          <a:xfrm>
+            <a:off x="9200800" y="5390000"/>
+            <a:ext cx="2229200" cy="220000"/>
+          </a:xfrm>
+          <a:prstGeom prst="rect">
+            <a:avLst/>
+          </a:prstGeom>
+          <a:noFill/>
+        </p:spPr>
+        <p:txBody>
+          <a:bodyPr wrap="square" lIns="0" rIns="0" tIns="0" bIns="0" anchor="t">
+            <a:spAutoFit/>
+          </a:bodyPr>
+          <a:lstStyle/>
+          <a:p>
+            <a:pPr algn="l"/>
+            <a:r>
+              <a:rPr sz="1000" b="0">
+                <a:solidFill>
+                  <a:srgbClr val="6B6A78"/>
+                </a:solidFill>
+                <a:latin typeface="Aptos"/>
+              </a:rPr>
+              <a:t>share of all 4,45,256 cases</a:t>
+            </a:r>
+          </a:p>
+        </p:txBody>
+      </p:sp>
+      <p:sp>
+        <p:nvSpPr>
+          <p:cNvPr id="42" name="TextBox 41"/>
+          <p:cNvSpPr txBox="1"/>
+          <p:nvPr/>
+        </p:nvSpPr>
+        <p:spPr>
+          <a:xfrm>
+            <a:off x="6400800" y="5720000"/>
+            <a:ext cx="5029200" cy="220000"/>
+          </a:xfrm>
+          <a:prstGeom prst="rect">
+            <a:avLst/>
+          </a:prstGeom>
+          <a:noFill/>
+        </p:spPr>
+        <p:txBody>
+          <a:bodyPr wrap="square" lIns="0" rIns="0" tIns="0" bIns="0" anchor="t">
+            <a:spAutoFit/>
+          </a:bodyPr>
+          <a:lstStyle/>
+          <a:p>
+            <a:pPr algn="l"/>
+            <a:r>
+              <a:rPr sz="1000" b="0">
+                <a:solidFill>
+                  <a:srgbClr val="6B6A78"/>
+                </a:solidFill>
+                <a:latin typeface="Aptos"/>
+              </a:rPr>
+              <a:t>Source: NCRB, Crime in India 2022</a:t>
+            </a:r>
+          </a:p>
+        </p:txBody>
+      </p:sp>
     </p:spTree>
   </p:cSld>
   <p:clrMapOvr>

</xml_diff>

<commit_message>
Deck slides 3-5: bullet points, solution modes and PINs, rebuilt demo slide with a legible screenshot
</commit_message>
<xml_diff>
--- a/docs/SparshaGuard_BIH2026.pptx
+++ b/docs/SparshaGuard_BIH2026.pptx
@@ -5676,7 +5676,7 @@
         <p:spPr>
           <a:xfrm>
             <a:off x="640080" y="1737360"/>
-            <a:ext cx="6766560" cy="1828800"/>
+            <a:ext cx="6766560" cy="2194560"/>
           </a:xfrm>
           <a:prstGeom prst="roundRect">
             <a:avLst/>
@@ -5722,7 +5722,7 @@
         <p:spPr>
           <a:xfrm>
             <a:off x="640080" y="1737360"/>
-            <a:ext cx="68580" cy="1828800"/>
+            <a:ext cx="68580" cy="2194560"/>
           </a:xfrm>
           <a:prstGeom prst="rect">
             <a:avLst/>
@@ -5803,7 +5803,7 @@
         <p:spPr>
           <a:xfrm>
             <a:off x="822959" y="2212848"/>
-            <a:ext cx="6446520" cy="1261872"/>
+            <a:ext cx="6446520" cy="1500000"/>
           </a:xfrm>
           <a:prstGeom prst="rect">
             <a:avLst/>
@@ -5816,15 +5816,159 @@
           </a:bodyPr>
           <a:lstStyle/>
           <a:p>
-            <a:pPr algn="l"/>
-            <a:r>
-              <a:rPr sz="1600" b="0">
+            <a:pPr marL="228600" indent="-228600">
+              <a:buFont typeface="Arial"/>
+              <a:buChar char="•"/>
+            </a:pPr>
+            <a:r>
+              <a:rPr lang="en-IN" sz="1400" b="1">
                 <a:solidFill>
                   <a:srgbClr val="2D2B39"/>
                 </a:solidFill>
                 <a:latin typeface="Aptos"/>
-              </a:rPr>
-              <a:t>A smartwatch that feels another person's touch. In Guard Mode, a stranger's grab, or her struggling to get free, starts a 15 s PIN countdown and turns the mic on. No PIN sends SMS, GPS and the voice recording, and calls 112.</a:t>
+                <a:cs typeface="Aptos"/>
+              </a:rPr>
+              <a:t>Touch-detecting smartwatch: </a:t>
+            </a:r>
+            <a:r>
+              <a:rPr lang="en-IN" sz="1400" b="0">
+                <a:solidFill>
+                  <a:srgbClr val="2D2B39"/>
+                </a:solidFill>
+                <a:latin typeface="Aptos"/>
+                <a:cs typeface="Aptos"/>
+              </a:rPr>
+              <a:t>senses another person's touch on her</a:t>
+            </a:r>
+          </a:p>
+          <a:p>
+            <a:pPr marL="228600" indent="-228600">
+              <a:buFont typeface="Arial"/>
+              <a:buChar char="•"/>
+            </a:pPr>
+            <a:r>
+              <a:rPr lang="en-IN" sz="1400" b="1">
+                <a:solidFill>
+                  <a:srgbClr val="2D2B39"/>
+                </a:solidFill>
+                <a:latin typeface="Aptos"/>
+                <a:cs typeface="Aptos"/>
+              </a:rPr>
+              <a:t>Normal mode: </a:t>
+            </a:r>
+            <a:r>
+              <a:rPr lang="en-IN" sz="1400" b="0">
+                <a:solidFill>
+                  <a:srgbClr val="2D2B39"/>
+                </a:solidFill>
+                <a:latin typeface="Aptos"/>
+                <a:cs typeface="Aptos"/>
+              </a:rPr>
+              <a:t>an everyday watch; touches raise no alarm</a:t>
+            </a:r>
+          </a:p>
+          <a:p>
+            <a:pPr marL="228600" indent="-228600">
+              <a:buFont typeface="Arial"/>
+              <a:buChar char="•"/>
+            </a:pPr>
+            <a:r>
+              <a:rPr lang="en-IN" sz="1400" b="1">
+                <a:solidFill>
+                  <a:srgbClr val="2D2B39"/>
+                </a:solidFill>
+                <a:latin typeface="Aptos"/>
+                <a:cs typeface="Aptos"/>
+              </a:rPr>
+              <a:t>Guard Mode: </a:t>
+            </a:r>
+            <a:r>
+              <a:rPr lang="en-IN" sz="1400" b="0">
+                <a:solidFill>
+                  <a:srgbClr val="2D2B39"/>
+                </a:solidFill>
+                <a:latin typeface="Aptos"/>
+                <a:cs typeface="Aptos"/>
+              </a:rPr>
+              <a:t>a stranger's grab or a struggle starts a 15 s PIN countdown; mic on</a:t>
+            </a:r>
+          </a:p>
+          <a:p>
+            <a:pPr marL="228600" indent="-228600">
+              <a:buFont typeface="Arial"/>
+              <a:buChar char="•"/>
+            </a:pPr>
+            <a:r>
+              <a:rPr lang="en-IN" sz="1400" b="1">
+                <a:solidFill>
+                  <a:srgbClr val="2D2B39"/>
+                </a:solidFill>
+                <a:latin typeface="Aptos"/>
+                <a:cs typeface="Aptos"/>
+              </a:rPr>
+              <a:t>Real PIN: </a:t>
+            </a:r>
+            <a:r>
+              <a:rPr lang="en-IN" sz="1400" b="0">
+                <a:solidFill>
+                  <a:srgbClr val="2D2B39"/>
+                </a:solidFill>
+                <a:latin typeface="Aptos"/>
+                <a:cs typeface="Aptos"/>
+              </a:rPr>
+              <a:t>cancels the alert and deletes the recording</a:t>
+            </a:r>
+          </a:p>
+          <a:p>
+            <a:pPr marL="228600" indent="-228600">
+              <a:buFont typeface="Arial"/>
+              <a:buChar char="•"/>
+            </a:pPr>
+            <a:r>
+              <a:rPr lang="en-IN" sz="1400" b="1">
+                <a:solidFill>
+                  <a:srgbClr val="2D2B39"/>
+                </a:solidFill>
+                <a:latin typeface="Aptos"/>
+                <a:cs typeface="Aptos"/>
+              </a:rPr>
+              <a:t>Duress PIN: </a:t>
+            </a:r>
+            <a:r>
+              <a:rPr lang="en-IN" sz="1400" b="0">
+                <a:solidFill>
+                  <a:srgbClr val="2D2B39"/>
+                </a:solidFill>
+                <a:latin typeface="Aptos"/>
+                <a:cs typeface="Aptos"/>
+              </a:rPr>
+              <a:t>shows "Cancelled" but alerts her contact silently</a:t>
+            </a:r>
+          </a:p>
+          <a:p>
+            <a:pPr marL="228600" indent="-228600">
+              <a:buFont typeface="Arial"/>
+              <a:buChar char="•"/>
+            </a:pPr>
+            <a:r>
+              <a:rPr lang="en-IN" sz="1400" b="1">
+                <a:solidFill>
+                  <a:srgbClr val="2D2B39"/>
+                </a:solidFill>
+                <a:latin typeface="Aptos"/>
+                <a:cs typeface="Aptos"/>
+              </a:rPr>
+              <a:t>No PIN: </a:t>
+            </a:r>
+            <a:r>
+              <a:rPr lang="en-IN" sz="1400" b="0">
+                <a:solidFill>
+                  <a:srgbClr val="2D2B39"/>
+                </a:solidFill>
+                <a:latin typeface="Aptos"/>
+                <a:cs typeface="Aptos"/>
+              </a:rPr>
+              <a:t>SMS + GPS + voice recording sent, 112 called</a:t>
             </a:r>
           </a:p>
         </p:txBody>
@@ -5838,7 +5982,7 @@
         <p:spPr>
           <a:xfrm>
             <a:off x="7635240" y="1737360"/>
-            <a:ext cx="3931920" cy="1828800"/>
+            <a:ext cx="3931920" cy="2194560"/>
           </a:xfrm>
           <a:prstGeom prst="roundRect">
             <a:avLst/>
@@ -5884,7 +6028,7 @@
         <p:spPr>
           <a:xfrm>
             <a:off x="7635240" y="1737360"/>
-            <a:ext cx="68580" cy="1828800"/>
+            <a:ext cx="68580" cy="2194560"/>
           </a:xfrm>
           <a:prstGeom prst="rect">
             <a:avLst/>
@@ -5999,7 +6143,7 @@
         </p:nvSpPr>
         <p:spPr>
           <a:xfrm>
-            <a:off x="685800" y="3977639"/>
+            <a:off x="685800" y="4206239"/>
             <a:ext cx="3200400" cy="320040"/>
           </a:xfrm>
           <a:prstGeom prst="rect">
@@ -6034,7 +6178,7 @@
         </p:nvSpPr>
         <p:spPr>
           <a:xfrm>
-            <a:off x="685800" y="4434840"/>
+            <a:off x="685800" y="4663440"/>
             <a:ext cx="3474720" cy="1051560"/>
           </a:xfrm>
           <a:prstGeom prst="roundRect">
@@ -6080,7 +6224,7 @@
         </p:nvSpPr>
         <p:spPr>
           <a:xfrm>
-            <a:off x="685800" y="4434840"/>
+            <a:off x="685800" y="4663440"/>
             <a:ext cx="68580" cy="1051560"/>
           </a:xfrm>
           <a:prstGeom prst="rect">
@@ -6126,7 +6270,7 @@
         </p:nvSpPr>
         <p:spPr>
           <a:xfrm>
-            <a:off x="868680" y="4544568"/>
+            <a:off x="868680" y="4773168"/>
             <a:ext cx="3154679" cy="320040"/>
           </a:xfrm>
           <a:prstGeom prst="rect">
@@ -6161,7 +6305,7 @@
         </p:nvSpPr>
         <p:spPr>
           <a:xfrm>
-            <a:off x="868680" y="4910327"/>
+            <a:off x="868680" y="5138927"/>
             <a:ext cx="3154679" cy="484631"/>
           </a:xfrm>
           <a:prstGeom prst="rect">
@@ -6196,7 +6340,7 @@
         </p:nvSpPr>
         <p:spPr>
           <a:xfrm>
-            <a:off x="4480560" y="4434840"/>
+            <a:off x="4480560" y="4663440"/>
             <a:ext cx="3474720" cy="1051560"/>
           </a:xfrm>
           <a:prstGeom prst="roundRect">
@@ -6242,7 +6386,7 @@
         </p:nvSpPr>
         <p:spPr>
           <a:xfrm>
-            <a:off x="4480560" y="4434840"/>
+            <a:off x="4480560" y="4663440"/>
             <a:ext cx="68580" cy="1051560"/>
           </a:xfrm>
           <a:prstGeom prst="rect">
@@ -6288,7 +6432,7 @@
         </p:nvSpPr>
         <p:spPr>
           <a:xfrm>
-            <a:off x="4663440" y="4544568"/>
+            <a:off x="4663440" y="4773168"/>
             <a:ext cx="3154679" cy="320040"/>
           </a:xfrm>
           <a:prstGeom prst="rect">
@@ -6323,7 +6467,7 @@
         </p:nvSpPr>
         <p:spPr>
           <a:xfrm>
-            <a:off x="4663440" y="4910327"/>
+            <a:off x="4663440" y="5138927"/>
             <a:ext cx="3154679" cy="484631"/>
           </a:xfrm>
           <a:prstGeom prst="rect">
@@ -6358,7 +6502,7 @@
         </p:nvSpPr>
         <p:spPr>
           <a:xfrm>
-            <a:off x="8275320" y="4434840"/>
+            <a:off x="8275320" y="4663440"/>
             <a:ext cx="3474720" cy="1051560"/>
           </a:xfrm>
           <a:prstGeom prst="roundRect">
@@ -6404,7 +6548,7 @@
         </p:nvSpPr>
         <p:spPr>
           <a:xfrm>
-            <a:off x="8275320" y="4434840"/>
+            <a:off x="8275320" y="4663440"/>
             <a:ext cx="68580" cy="1051560"/>
           </a:xfrm>
           <a:prstGeom prst="rect">
@@ -6450,7 +6594,7 @@
         </p:nvSpPr>
         <p:spPr>
           <a:xfrm>
-            <a:off x="8458200" y="4544568"/>
+            <a:off x="8458200" y="4773168"/>
             <a:ext cx="3154679" cy="320040"/>
           </a:xfrm>
           <a:prstGeom prst="rect">
@@ -6485,7 +6629,7 @@
         </p:nvSpPr>
         <p:spPr>
           <a:xfrm>
-            <a:off x="8458200" y="4910327"/>
+            <a:off x="8458200" y="5138927"/>
             <a:ext cx="3154679" cy="484631"/>
           </a:xfrm>
           <a:prstGeom prst="rect">
@@ -7502,7 +7646,7 @@
         <p:spPr>
           <a:xfrm>
             <a:off x="685800" y="3794760"/>
-            <a:ext cx="5257800" cy="1554480"/>
+            <a:ext cx="5257800" cy="1737360"/>
           </a:xfrm>
           <a:prstGeom prst="roundRect">
             <a:avLst/>
@@ -7548,7 +7692,7 @@
         <p:spPr>
           <a:xfrm>
             <a:off x="685800" y="3794760"/>
-            <a:ext cx="68580" cy="1554480"/>
+            <a:ext cx="68580" cy="1737360"/>
           </a:xfrm>
           <a:prstGeom prst="rect">
             <a:avLst/>
@@ -7733,7 +7877,7 @@
         <p:spPr>
           <a:xfrm>
             <a:off x="6217920" y="3794760"/>
-            <a:ext cx="5257800" cy="1554480"/>
+            <a:ext cx="5257800" cy="1737360"/>
           </a:xfrm>
           <a:prstGeom prst="roundRect">
             <a:avLst/>
@@ -7779,7 +7923,7 @@
         <p:spPr>
           <a:xfrm>
             <a:off x="6217920" y="3794760"/>
-            <a:ext cx="68580" cy="1554480"/>
+            <a:ext cx="68580" cy="1737360"/>
           </a:xfrm>
           <a:prstGeom prst="rect">
             <a:avLst/>
@@ -7860,7 +8004,7 @@
         <p:spPr>
           <a:xfrm>
             <a:off x="6400800" y="4270248"/>
-            <a:ext cx="4937760" cy="987552"/>
+            <a:ext cx="4937760" cy="1250000"/>
           </a:xfrm>
           <a:prstGeom prst="rect">
             <a:avLst/>
@@ -7873,15 +8017,67 @@
           </a:bodyPr>
           <a:lstStyle/>
           <a:p>
-            <a:pPr algn="l"/>
-            <a:r>
-              <a:rPr sz="1400" b="0">
+            <a:pPr marL="228600" indent="-228600">
+              <a:buFont typeface="Arial"/>
+              <a:buChar char="•"/>
+            </a:pPr>
+            <a:r>
+              <a:rPr lang="en-IN" sz="1400" b="0">
                 <a:solidFill>
                   <a:srgbClr val="2D2B39"/>
                 </a:solidFill>
                 <a:latin typeface="Aptos"/>
-              </a:rPr>
-              <a:t>Low-cost parts, battery-powered, every decision on the watch. Each value is traced to a published source (60 logged), and two independent solvers confirm the physics.</a:t>
+                <a:cs typeface="Aptos"/>
+              </a:rPr>
+              <a:t>Low-cost parts, battery-powered</a:t>
+            </a:r>
+          </a:p>
+          <a:p>
+            <a:pPr marL="228600" indent="-228600">
+              <a:buFont typeface="Arial"/>
+              <a:buChar char="•"/>
+            </a:pPr>
+            <a:r>
+              <a:rPr lang="en-IN" sz="1400" b="0">
+                <a:solidFill>
+                  <a:srgbClr val="2D2B39"/>
+                </a:solidFill>
+                <a:latin typeface="Aptos"/>
+                <a:cs typeface="Aptos"/>
+              </a:rPr>
+              <a:t>Every decision made on the watch itself</a:t>
+            </a:r>
+          </a:p>
+          <a:p>
+            <a:pPr marL="228600" indent="-228600">
+              <a:buFont typeface="Arial"/>
+              <a:buChar char="•"/>
+            </a:pPr>
+            <a:r>
+              <a:rPr lang="en-IN" sz="1400" b="0">
+                <a:solidFill>
+                  <a:srgbClr val="2D2B39"/>
+                </a:solidFill>
+                <a:latin typeface="Aptos"/>
+                <a:cs typeface="Aptos"/>
+              </a:rPr>
+              <a:t>Each value traced to a published source (60 logged)</a:t>
+            </a:r>
+          </a:p>
+          <a:p>
+            <a:pPr marL="228600" indent="-228600">
+              <a:buFont typeface="Arial"/>
+              <a:buChar char="•"/>
+            </a:pPr>
+            <a:r>
+              <a:rPr lang="en-IN" sz="1400" b="0">
+                <a:solidFill>
+                  <a:srgbClr val="2D2B39"/>
+                </a:solidFill>
+                <a:latin typeface="Aptos"/>
+                <a:cs typeface="Aptos"/>
+              </a:rPr>
+              <a:t>Physics cross-checked by two solvers (ngspice, FastCap)</a:t>
             </a:r>
           </a:p>
         </p:txBody>
@@ -8272,7 +8468,7 @@
         <p:spPr>
           <a:xfrm>
             <a:off x="685800" y="1737360"/>
-            <a:ext cx="3429000" cy="3429000"/>
+            <a:ext cx="3276000" cy="4297680"/>
           </a:xfrm>
           <a:prstGeom prst="roundRect">
             <a:avLst/>
@@ -8318,7 +8514,7 @@
         <p:spPr>
           <a:xfrm>
             <a:off x="685800" y="1737360"/>
-            <a:ext cx="68580" cy="3429000"/>
+            <a:ext cx="68580" cy="4297680"/>
           </a:xfrm>
           <a:prstGeom prst="rect">
             <a:avLst/>
@@ -8357,49 +8553,14 @@
       </p:sp>
       <p:sp>
         <p:nvSpPr>
-          <p:cNvPr id="13" name="TextBox 12"/>
-          <p:cNvSpPr txBox="1"/>
-          <p:nvPr/>
-        </p:nvSpPr>
-        <p:spPr>
-          <a:xfrm>
-            <a:off x="868680" y="1847088"/>
-            <a:ext cx="3108960" cy="320040"/>
-          </a:xfrm>
-          <a:prstGeom prst="rect">
-            <a:avLst/>
-          </a:prstGeom>
-          <a:noFill/>
-        </p:spPr>
-        <p:txBody>
-          <a:bodyPr wrap="square" lIns="54864" tIns="18288" rIns="54864" bIns="18288" anchor="ctr">
-            <a:spAutoFit/>
-          </a:bodyPr>
-          <a:lstStyle/>
-          <a:p>
-            <a:pPr algn="l"/>
-            <a:r>
-              <a:rPr sz="1500" b="1">
-                <a:solidFill>
-                  <a:srgbClr val="191B5C"/>
-                </a:solidFill>
-                <a:latin typeface="Aptos"/>
-              </a:rPr>
-              <a:t>Feature 01</a:t>
-            </a:r>
-          </a:p>
-        </p:txBody>
-      </p:sp>
-      <p:sp>
-        <p:nvSpPr>
           <p:cNvPr id="14" name="TextBox 13"/>
           <p:cNvSpPr txBox="1"/>
           <p:nvPr/>
         </p:nvSpPr>
         <p:spPr>
           <a:xfrm>
-            <a:off x="868680" y="2212848"/>
-            <a:ext cx="3108960" cy="2862072"/>
+            <a:off x="868680" y="1847088"/>
+            <a:ext cx="2930240" cy="4097680"/>
           </a:xfrm>
           <a:prstGeom prst="rect">
             <a:avLst/>
@@ -8412,47 +8573,181 @@
           </a:bodyPr>
           <a:lstStyle/>
           <a:p>
-            <a:pPr algn="l"/>
-            <a:r>
-              <a:rPr sz="1500" b="1">
+            <a:pPr>
+              <a:buNone/>
+            </a:pPr>
+            <a:r>
+              <a:rPr lang="en-IN" sz="1200" b="1">
+                <a:solidFill>
+                  <a:srgbClr val="191B5C"/>
+                </a:solidFill>
+                <a:latin typeface="Aptos"/>
+                <a:cs typeface="Aptos"/>
+              </a:rPr>
+              <a:t>Feature 01 · Digital twin</a:t>
+            </a:r>
+          </a:p>
+          <a:p>
+            <a:pPr marL="228600" indent="-228600">
+              <a:buFont typeface="Arial"/>
+              <a:buChar char="•"/>
+            </a:pPr>
+            <a:r>
+              <a:rPr lang="en-IN" sz="1200" b="0">
                 <a:solidFill>
                   <a:srgbClr val="2D2B39"/>
                 </a:solidFill>
                 <a:latin typeface="Aptos"/>
-              </a:rPr>
-              <a:t>Digital-twin demo</a:t>
-            </a:r>
-          </a:p>
-          <a:p>
-            <a:pPr algn="l"/>
-            <a:endParaRPr sz="1500"/>
-          </a:p>
-          <a:p>
-            <a:pPr algn="l"/>
-            <a:r>
-              <a:rPr sz="1500" b="0">
+                <a:cs typeface="Aptos"/>
+              </a:rPr>
+              <a:t>The watch's own firmware on a simulated sensor</a:t>
+            </a:r>
+          </a:p>
+          <a:p>
+            <a:pPr marL="228600" indent="-228600">
+              <a:buFont typeface="Arial"/>
+              <a:buChar char="•"/>
+            </a:pPr>
+            <a:r>
+              <a:rPr lang="en-IN" sz="1200" b="0">
                 <a:solidFill>
                   <a:srgbClr val="2D2B39"/>
                 </a:solidFill>
                 <a:latin typeface="Aptos"/>
-              </a:rPr>
-              <a:t>The watch's own firmware runs on a simulated sensor: frequency sweeps, body static at 500 Hz, accelerometer, gyroscope and heart rate.</a:t>
-            </a:r>
-          </a:p>
-          <a:p>
-            <a:pPr algn="l"/>
-            <a:endParaRPr sz="1500"/>
-          </a:p>
-          <a:p>
-            <a:pPr algn="l"/>
-            <a:r>
-              <a:rPr sz="1500" b="0">
+                <a:cs typeface="Aptos"/>
+              </a:rPr>
+              <a:t>Sensors: frequency sweep, body static (500 Hz), accelerometer, gyroscope, heart rate</a:t>
+            </a:r>
+          </a:p>
+          <a:p>
+            <a:pPr marL="228600" indent="-228600">
+              <a:buFont typeface="Arial"/>
+              <a:buChar char="•"/>
+            </a:pPr>
+            <a:r>
+              <a:rPr lang="en-IN" sz="1200" b="0">
                 <a:solidFill>
                   <a:srgbClr val="2D2B39"/>
                 </a:solidFill>
                 <a:latin typeface="Aptos"/>
-              </a:rPr>
-              <a:t>Guided story and try-it mode: grabs, struggle, running, PIN, duress, strap removal.</a:t>
+                <a:cs typeface="Aptos"/>
+              </a:rPr>
+              <a:t>Guided story + try-it mode: grabs, struggle, running, PIN, duress, strap removal</a:t>
+            </a:r>
+          </a:p>
+          <a:p>
+            <a:pPr>
+              <a:spcBef>
+                <a:spcPts val="900"/>
+              </a:spcBef>
+              <a:buNone/>
+            </a:pPr>
+            <a:r>
+              <a:rPr lang="en-IN" sz="1200" b="1">
+                <a:solidFill>
+                  <a:srgbClr val="191B5C"/>
+                </a:solidFill>
+                <a:latin typeface="Aptos"/>
+                <a:cs typeface="Aptos"/>
+              </a:rPr>
+              <a:t>Feature 02 · Validated physics</a:t>
+            </a:r>
+          </a:p>
+          <a:p>
+            <a:pPr marL="228600" indent="-228600">
+              <a:buFont typeface="Arial"/>
+              <a:buChar char="•"/>
+            </a:pPr>
+            <a:r>
+              <a:rPr lang="en-IN" sz="1200" b="0">
+                <a:solidFill>
+                  <a:srgbClr val="2D2B39"/>
+                </a:solidFill>
+                <a:latin typeface="Aptos"/>
+                <a:cs typeface="Aptos"/>
+              </a:rPr>
+              <a:t>Values from 60 published sources</a:t>
+            </a:r>
+          </a:p>
+          <a:p>
+            <a:pPr marL="228600" indent="-228600">
+              <a:buFont typeface="Arial"/>
+              <a:buChar char="•"/>
+            </a:pPr>
+            <a:r>
+              <a:rPr lang="en-IN" sz="1200" b="0">
+                <a:solidFill>
+                  <a:srgbClr val="2D2B39"/>
+                </a:solidFill>
+                <a:latin typeface="Aptos"/>
+                <a:cs typeface="Aptos"/>
+              </a:rPr>
+              <a:t>Circuit matches SPICE to 0.0001 %; 3D field matches MIT FastCap within 1 %</a:t>
+            </a:r>
+          </a:p>
+          <a:p>
+            <a:pPr marL="228600" indent="-228600">
+              <a:buFont typeface="Arial"/>
+              <a:buChar char="•"/>
+            </a:pPr>
+            <a:r>
+              <a:rPr lang="en-IN" sz="1200" b="0">
+                <a:solidFill>
+                  <a:srgbClr val="2D2B39"/>
+                </a:solidFill>
+                <a:latin typeface="Aptos"/>
+                <a:cs typeface="Aptos"/>
+              </a:rPr>
+              <a:t>70 % of grabs over 7 body places (13 % before); 99 % of struggles</a:t>
+            </a:r>
+          </a:p>
+          <a:p>
+            <a:pPr marL="228600" indent="-228600">
+              <a:buFont typeface="Arial"/>
+              <a:buChar char="•"/>
+            </a:pPr>
+            <a:r>
+              <a:rPr lang="en-IN" sz="1200" b="0">
+                <a:solidFill>
+                  <a:srgbClr val="2D2B39"/>
+                </a:solidFill>
+                <a:latin typeface="Aptos"/>
+                <a:cs typeface="Aptos"/>
+              </a:rPr>
+              <a:t>0–1 unwanted prompts in 9 simulated hours</a:t>
+            </a:r>
+          </a:p>
+          <a:p>
+            <a:pPr>
+              <a:spcBef>
+                <a:spcPts val="900"/>
+              </a:spcBef>
+              <a:buNone/>
+            </a:pPr>
+            <a:r>
+              <a:rPr lang="en-IN" sz="1200" b="1">
+                <a:solidFill>
+                  <a:srgbClr val="191B5C"/>
+                </a:solidFill>
+                <a:latin typeface="Aptos"/>
+                <a:cs typeface="Aptos"/>
+              </a:rPr>
+              <a:t>Try it</a:t>
+            </a:r>
+          </a:p>
+          <a:p>
+            <a:pPr>
+              <a:buNone/>
+            </a:pPr>
+            <a:r>
+              <a:rPr lang="en-IN" sz="1200" b="0">
+                <a:solidFill>
+                  <a:srgbClr val="2D2B39"/>
+                </a:solidFill>
+                <a:latin typeface="Aptos"/>
+                <a:cs typeface="Aptos"/>
+              </a:rPr>
+              <a:t>bhajanth13.github.io/SparshaGuard</a:t>
             </a:r>
           </a:p>
         </p:txBody>
@@ -8465,8 +8760,8 @@
         </p:nvSpPr>
         <p:spPr>
           <a:xfrm>
-            <a:off x="4389120" y="1737360"/>
-            <a:ext cx="3429000" cy="3429000"/>
+            <a:off x="4161800" y="1737360"/>
+            <a:ext cx="3276000" cy="4297680"/>
           </a:xfrm>
           <a:prstGeom prst="roundRect">
             <a:avLst/>
@@ -8511,8 +8806,8 @@
         </p:nvSpPr>
         <p:spPr>
           <a:xfrm>
-            <a:off x="4389120" y="1737360"/>
-            <a:ext cx="68580" cy="3429000"/>
+            <a:off x="4161800" y="1737360"/>
+            <a:ext cx="68580" cy="4297680"/>
           </a:xfrm>
           <a:prstGeom prst="rect">
             <a:avLst/>
@@ -8551,49 +8846,14 @@
       </p:sp>
       <p:sp>
         <p:nvSpPr>
-          <p:cNvPr id="17" name="TextBox 16"/>
-          <p:cNvSpPr txBox="1"/>
-          <p:nvPr/>
-        </p:nvSpPr>
-        <p:spPr>
-          <a:xfrm>
-            <a:off x="4572000" y="1847088"/>
-            <a:ext cx="3108960" cy="320040"/>
-          </a:xfrm>
-          <a:prstGeom prst="rect">
-            <a:avLst/>
-          </a:prstGeom>
-          <a:noFill/>
-        </p:spPr>
-        <p:txBody>
-          <a:bodyPr wrap="square" lIns="54864" tIns="18288" rIns="54864" bIns="18288" anchor="ctr">
-            <a:spAutoFit/>
-          </a:bodyPr>
-          <a:lstStyle/>
-          <a:p>
-            <a:pPr algn="l"/>
-            <a:r>
-              <a:rPr sz="1500" b="1">
-                <a:solidFill>
-                  <a:srgbClr val="191B5C"/>
-                </a:solidFill>
-                <a:latin typeface="Aptos"/>
-              </a:rPr>
-              <a:t>Feature 02</a:t>
-            </a:r>
-          </a:p>
-        </p:txBody>
-      </p:sp>
-      <p:sp>
-        <p:nvSpPr>
           <p:cNvPr id="18" name="TextBox 17"/>
           <p:cNvSpPr txBox="1"/>
           <p:nvPr/>
         </p:nvSpPr>
         <p:spPr>
           <a:xfrm>
-            <a:off x="4572000" y="2212848"/>
-            <a:ext cx="3108960" cy="2862072"/>
+            <a:off x="4344680" y="1847088"/>
+            <a:ext cx="2930240" cy="4097680"/>
           </a:xfrm>
           <a:prstGeom prst="rect">
             <a:avLst/>
@@ -8606,47 +8866,174 @@
           </a:bodyPr>
           <a:lstStyle/>
           <a:p>
-            <a:pPr algn="l"/>
-            <a:r>
-              <a:rPr sz="1500" b="1">
+            <a:pPr>
+              <a:buNone/>
+            </a:pPr>
+            <a:r>
+              <a:rPr lang="en-IN" sz="1200" b="1">
+                <a:solidFill>
+                  <a:srgbClr val="191B5C"/>
+                </a:solidFill>
+                <a:latin typeface="Aptos"/>
+                <a:cs typeface="Aptos"/>
+              </a:rPr>
+              <a:t>What the screenshot shows</a:t>
+            </a:r>
+          </a:p>
+          <a:p>
+            <a:pPr marL="228600" indent="-228600">
+              <a:buFont typeface="Arial"/>
+              <a:buChar char="•"/>
+            </a:pPr>
+            <a:r>
+              <a:rPr lang="en-IN" sz="1200" b="1">
                 <a:solidFill>
                   <a:srgbClr val="2D2B39"/>
                 </a:solidFill>
                 <a:latin typeface="Aptos"/>
-              </a:rPr>
-              <a:t>Validated physics model</a:t>
-            </a:r>
-          </a:p>
-          <a:p>
-            <a:pPr algn="l"/>
-            <a:endParaRPr sz="1500"/>
-          </a:p>
-          <a:p>
-            <a:pPr algn="l"/>
-            <a:r>
-              <a:rPr sz="1500" b="0">
+                <a:cs typeface="Aptos"/>
+              </a:rPr>
+              <a:t>Moment: </a:t>
+            </a:r>
+            <a:r>
+              <a:rPr lang="en-IN" sz="1200" b="0">
                 <a:solidFill>
                   <a:srgbClr val="2D2B39"/>
                 </a:solidFill>
                 <a:latin typeface="Aptos"/>
-              </a:rPr>
-              <a:t>Values from 60 published sources. Solver matches SPICE to 0.0001 %; 3D field matches MIT FastCap within 1 %.</a:t>
-            </a:r>
-          </a:p>
-          <a:p>
-            <a:pPr algn="l"/>
-            <a:endParaRPr sz="1500"/>
-          </a:p>
-          <a:p>
-            <a:pPr algn="l"/>
-            <a:r>
-              <a:rPr sz="1500" b="0">
+                <a:cs typeface="Aptos"/>
+              </a:rPr>
+              <a:t>Guard Mode on; a stranger grabs her wrist</a:t>
+            </a:r>
+          </a:p>
+          <a:p>
+            <a:pPr marL="228600" indent="-228600">
+              <a:buFont typeface="Arial"/>
+              <a:buChar char="•"/>
+            </a:pPr>
+            <a:r>
+              <a:rPr lang="en-IN" sz="1200" b="1">
                 <a:solidFill>
                   <a:srgbClr val="2D2B39"/>
                 </a:solidFill>
                 <a:latin typeface="Aptos"/>
-              </a:rPr>
-              <a:t>70 % of grabs over 7 body places (13 % before), 99 % of struggles; 0–1 unwanted prompts in 9 h.</a:t>
+                <a:cs typeface="Aptos"/>
+              </a:rPr>
+              <a:t>Watch face: </a:t>
+            </a:r>
+            <a:r>
+              <a:rPr lang="en-IN" sz="1200" b="0">
+                <a:solidFill>
+                  <a:srgbClr val="2D2B39"/>
+                </a:solidFill>
+                <a:latin typeface="Aptos"/>
+                <a:cs typeface="Aptos"/>
+              </a:rPr>
+              <a:t>asks for her PIN, 11 s of 15 left; red dot = mic recording</a:t>
+            </a:r>
+          </a:p>
+          <a:p>
+            <a:pPr marL="228600" indent="-228600">
+              <a:buFont typeface="Arial"/>
+              <a:buChar char="•"/>
+            </a:pPr>
+            <a:r>
+              <a:rPr lang="en-IN" sz="1200" b="1">
+                <a:solidFill>
+                  <a:srgbClr val="2D2B39"/>
+                </a:solidFill>
+                <a:latin typeface="Aptos"/>
+                <a:cs typeface="Aptos"/>
+              </a:rPr>
+              <a:t>Orange ring: </a:t>
+            </a:r>
+            <a:r>
+              <a:rPr lang="en-IN" sz="1200" b="0">
+                <a:solidFill>
+                  <a:srgbClr val="2D2B39"/>
+                </a:solidFill>
+                <a:latin typeface="Aptos"/>
+                <a:cs typeface="Aptos"/>
+              </a:rPr>
+              <a:t>the PIN countdown</a:t>
+            </a:r>
+          </a:p>
+          <a:p>
+            <a:pPr marL="228600" indent="-228600">
+              <a:buFont typeface="Arial"/>
+              <a:buChar char="•"/>
+            </a:pPr>
+            <a:r>
+              <a:rPr lang="en-IN" sz="1200" b="1">
+                <a:solidFill>
+                  <a:srgbClr val="2D2B39"/>
+                </a:solidFill>
+                <a:latin typeface="Aptos"/>
+                <a:cs typeface="Aptos"/>
+              </a:rPr>
+              <a:t>Sensor signal (log scale, last 30 s): </a:t>
+            </a:r>
+            <a:r>
+              <a:rPr lang="en-IN" sz="1200" b="0">
+                <a:solidFill>
+                  <a:srgbClr val="2D2B39"/>
+                </a:solidFill>
+                <a:latin typeface="Aptos"/>
+                <a:cs typeface="Aptos"/>
+              </a:rPr>
+              <a:t>jumps from about 0.1 % to 16 %, far above the 0.3 % touch threshold (dashed); shaded = touch felt</a:t>
+            </a:r>
+          </a:p>
+          <a:p>
+            <a:pPr marL="228600" indent="-228600">
+              <a:buFont typeface="Arial"/>
+              <a:buChar char="•"/>
+            </a:pPr>
+            <a:r>
+              <a:rPr lang="en-IN" sz="1200" b="1">
+                <a:solidFill>
+                  <a:srgbClr val="2D2B39"/>
+                </a:solidFill>
+                <a:latin typeface="Aptos"/>
+                <a:cs typeface="Aptos"/>
+              </a:rPr>
+              <a:t>Static on her body: </a:t>
+            </a:r>
+            <a:r>
+              <a:rPr lang="en-IN" sz="1200" b="0">
+                <a:solidFill>
+                  <a:srgbClr val="2D2B39"/>
+                </a:solidFill>
+                <a:latin typeface="Aptos"/>
+                <a:cs typeface="Aptos"/>
+              </a:rPr>
+              <a:t>the red line marks the instant another body touched her (charge shared); orange ticks = arm jerks from the pull</a:t>
+            </a:r>
+          </a:p>
+          <a:p>
+            <a:pPr marL="228600" indent="-228600">
+              <a:buFont typeface="Arial"/>
+              <a:buChar char="•"/>
+            </a:pPr>
+            <a:r>
+              <a:rPr lang="en-IN" sz="1200" b="1">
+                <a:solidFill>
+                  <a:srgbClr val="2D2B39"/>
+                </a:solidFill>
+                <a:latin typeface="Aptos"/>
+                <a:cs typeface="Aptos"/>
+              </a:rPr>
+              <a:t>Decision: </a:t>
+            </a:r>
+            <a:r>
+              <a:rPr lang="en-IN" sz="1200" b="0">
+                <a:solidFill>
+                  <a:srgbClr val="2D2B39"/>
+                </a:solidFill>
+                <a:latin typeface="Aptos"/>
+                <a:cs typeface="Aptos"/>
+              </a:rPr>
+              <a:t>touch held 2 s + another body = PIN prompt; no PIN in 15 s sends the alert</a:t>
             </a:r>
           </a:p>
         </p:txBody>
@@ -8659,8 +9046,8 @@
         </p:nvSpPr>
         <p:spPr>
           <a:xfrm>
-            <a:off x="8092440" y="1737360"/>
-            <a:ext cx="3429000" cy="3429000"/>
+            <a:off x="7637800" y="1737360"/>
+            <a:ext cx="3883640" cy="4297680"/>
           </a:xfrm>
           <a:prstGeom prst="roundRect">
             <a:avLst/>
@@ -8705,8 +9092,8 @@
         </p:nvSpPr>
         <p:spPr>
           <a:xfrm>
-            <a:off x="8321040" y="1920240"/>
-            <a:ext cx="2971800" cy="320040"/>
+            <a:off x="7820680" y="1797360"/>
+            <a:ext cx="3517880" cy="320040"/>
           </a:xfrm>
           <a:prstGeom prst="rect">
             <a:avLst/>
@@ -8721,104 +9108,13 @@
           <a:p>
             <a:pPr algn="ctr"/>
             <a:r>
-              <a:rPr sz="1400" b="1">
+              <a:rPr sz="1300" b="1">
                 <a:solidFill>
                   <a:srgbClr val="191B5C"/>
                 </a:solidFill>
                 <a:latin typeface="Aptos"/>
               </a:rPr>
-              <a:t>SCREENSHOT / DEMO</a:t>
-            </a:r>
-          </a:p>
-        </p:txBody>
-      </p:sp>
-      <p:pic xmlns:p="http://schemas.openxmlformats.org/presentationml/2006/main" xmlns:a="http://schemas.openxmlformats.org/drawingml/2006/main" xmlns:r="http://schemas.openxmlformats.org/officeDocument/2006/relationships">
-        <p:nvPicPr>
-          <p:cNvPr id="90" name="Demo screenshot" descr="SparshaGuard digital-twin demo: a shoulder grab. The sweep stays near 0.1 %, but the static voltage on her body jumps when another body touches her, arm jerks follow, and the watch asks for the PIN"/>
-          <p:cNvPicPr>
-            <a:picLocks noChangeAspect="1"/>
-          </p:cNvPicPr>
-          <p:nvPr/>
-        </p:nvPicPr>
-        <p:blipFill>
-          <a:blip r:embed="rIdDemo"/>
-          <a:stretch>
-            <a:fillRect/>
-          </a:stretch>
-        </p:blipFill>
-        <p:spPr>
-          <a:xfrm>
-            <a:off x="8503919" y="2331720"/>
-            <a:ext cx="2606040" cy="2352254"/>
-          </a:xfrm>
-          <a:prstGeom prst="rect">
-            <a:avLst/>
-          </a:prstGeom>
-          <a:ln w="9525">
-            <a:solidFill>
-              <a:srgbClr val="DDDBE4"/>
-            </a:solidFill>
-          </a:ln>
-        </p:spPr>
-      </p:pic>
-      <p:sp>
-        <p:nvSpPr>
-          <p:cNvPr id="23" name="TextBox 22"/>
-          <p:cNvSpPr txBox="1"/>
-          <p:nvPr/>
-        </p:nvSpPr>
-        <p:spPr>
-          <a:xfrm>
-            <a:off x="731520" y="5532120"/>
-            <a:ext cx="10789920" cy="320040"/>
-          </a:xfrm>
-          <a:prstGeom prst="rect">
-            <a:avLst/>
-          </a:prstGeom>
-          <a:noFill/>
-        </p:spPr>
-        <p:txBody>
-          <a:bodyPr wrap="square" lIns="54864" tIns="18288" rIns="54864" bIns="18288" anchor="ctr">
-            <a:spAutoFit/>
-          </a:bodyPr>
-          <a:lstStyle/>
-          <a:p>
-            <a:pPr algn="l"/>
-            <a:r>
-              <a:rPr sz="1400" b="1">
-                <a:solidFill>
-                  <a:srgbClr val="5B2278"/>
-                </a:solidFill>
-                <a:latin typeface="Aptos"/>
-              </a:rPr>
-              <a:t xml:space="preserve">Live demo + explorer: </a:t>
-            </a:r>
-            <a:r>
-              <a:rPr sz="1400" b="0">
-                <a:solidFill>
-                  <a:srgbClr val="5B2278"/>
-                </a:solidFill>
-                <a:latin typeface="Aptos"/>
-              </a:rPr>
-              <a:t>bhajanth13.github.io/SparshaGuard</a:t>
-            </a:r>
-            <a:r>
-              <a:rPr sz="1400" b="1">
-                <a:solidFill>
-                  <a:srgbClr val="5B2278"/>
-                </a:solidFill>
-                <a:latin typeface="Aptos"/>
-              </a:rPr>
-              <a:t xml:space="preserve">    Code: </a:t>
-            </a:r>
-            <a:r>
-              <a:rPr sz="1400" b="0">
-                <a:solidFill>
-                  <a:srgbClr val="5B2278"/>
-                </a:solidFill>
-                <a:latin typeface="Aptos"/>
-              </a:rPr>
-              <a:t>github.com/Bhajanth13/SparshaGuard</a:t>
+              <a:t>SCREENSHOT · DIGITAL TWIN</a:t>
             </a:r>
           </a:p>
         </p:txBody>
@@ -8848,6 +9144,30 @@
           <a:xfrm>
             <a:off x="314632" y="203980"/>
             <a:ext cx="1742768" cy="555994"/>
+          </a:xfrm>
+          <a:prstGeom prst="rect">
+            <a:avLst/>
+          </a:prstGeom>
+        </p:spPr>
+      </p:pic>
+      <p:pic>
+        <p:nvPicPr>
+          <p:cNvPr id="26" name="Demo screenshot" descr="s5_shot.png"/>
+          <p:cNvPicPr>
+            <a:picLocks noChangeAspect="1"/>
+          </p:cNvPicPr>
+          <p:nvPr/>
+        </p:nvPicPr>
+        <p:blipFill>
+          <a:blip r:embed="rId4"/>
+          <a:stretch>
+            <a:fillRect/>
+          </a:stretch>
+        </p:blipFill>
+        <p:spPr>
+          <a:xfrm>
+            <a:off x="7776491" y="2067360"/>
+            <a:ext cx="3606258" cy="3747680"/>
           </a:xfrm>
           <a:prstGeom prst="rect">
             <a:avLst/>

</xml_diff>

<commit_message>
Deck slide 5: shorter, crisper feature and screenshot bullets
</commit_message>
<xml_diff>
--- a/docs/SparshaGuard_BIH2026.pptx
+++ b/docs/SparshaGuard_BIH2026.pptx
@@ -8577,7 +8577,7 @@
               <a:buNone/>
             </a:pPr>
             <a:r>
-              <a:rPr lang="en-IN" sz="1200" b="1">
+              <a:rPr lang="en-IN" sz="1300" b="1">
                 <a:solidFill>
                   <a:srgbClr val="191B5C"/>
                 </a:solidFill>
@@ -8589,61 +8589,70 @@
           </a:p>
           <a:p>
             <a:pPr marL="228600" indent="-228600">
+              <a:spcBef>
+                <a:spcPts val="400"/>
+              </a:spcBef>
               <a:buFont typeface="Arial"/>
               <a:buChar char="•"/>
             </a:pPr>
             <a:r>
-              <a:rPr lang="en-IN" sz="1200" b="0">
+              <a:rPr lang="en-IN" sz="1300" b="0">
                 <a:solidFill>
                   <a:srgbClr val="2D2B39"/>
                 </a:solidFill>
                 <a:latin typeface="Aptos"/>
                 <a:cs typeface="Aptos"/>
               </a:rPr>
-              <a:t>The watch's own firmware on a simulated sensor</a:t>
+              <a:t>Real firmware, simulated body</a:t>
             </a:r>
           </a:p>
           <a:p>
             <a:pPr marL="228600" indent="-228600">
+              <a:spcBef>
+                <a:spcPts val="400"/>
+              </a:spcBef>
               <a:buFont typeface="Arial"/>
               <a:buChar char="•"/>
             </a:pPr>
             <a:r>
-              <a:rPr lang="en-IN" sz="1200" b="0">
+              <a:rPr lang="en-IN" sz="1300" b="0">
                 <a:solidFill>
                   <a:srgbClr val="2D2B39"/>
                 </a:solidFill>
                 <a:latin typeface="Aptos"/>
                 <a:cs typeface="Aptos"/>
               </a:rPr>
-              <a:t>Sensors: frequency sweep, body static (500 Hz), accelerometer, gyroscope, heart rate</a:t>
+              <a:t>Sweep, static, motion, heart rate</a:t>
             </a:r>
           </a:p>
           <a:p>
             <a:pPr marL="228600" indent="-228600">
+              <a:spcBef>
+                <a:spcPts val="400"/>
+              </a:spcBef>
               <a:buFont typeface="Arial"/>
               <a:buChar char="•"/>
             </a:pPr>
             <a:r>
-              <a:rPr lang="en-IN" sz="1200" b="0">
+              <a:rPr lang="en-IN" sz="1300" b="0">
                 <a:solidFill>
                   <a:srgbClr val="2D2B39"/>
                 </a:solidFill>
                 <a:latin typeface="Aptos"/>
                 <a:cs typeface="Aptos"/>
               </a:rPr>
-              <a:t>Guided story + try-it mode: grabs, struggle, running, PIN, duress, strap removal</a:t>
+              <a:t>Try grabs, struggle, PIN, duress</a:t>
             </a:r>
           </a:p>
           <a:p>
             <a:pPr>
               <a:spcBef>
-                <a:spcPts val="900"/>
+                <a:spcPts val="1400"/>
               </a:spcBef>
               <a:buNone/>
             </a:pPr>
             <a:r>
-              <a:rPr lang="en-IN" sz="1200" b="1">
+              <a:rPr lang="en-IN" sz="1300" b="1">
                 <a:solidFill>
                   <a:srgbClr val="191B5C"/>
                 </a:solidFill>
@@ -8655,77 +8664,108 @@
           </a:p>
           <a:p>
             <a:pPr marL="228600" indent="-228600">
+              <a:spcBef>
+                <a:spcPts val="400"/>
+              </a:spcBef>
               <a:buFont typeface="Arial"/>
               <a:buChar char="•"/>
             </a:pPr>
             <a:r>
-              <a:rPr lang="en-IN" sz="1200" b="0">
+              <a:rPr lang="en-IN" sz="1300" b="0">
                 <a:solidFill>
                   <a:srgbClr val="2D2B39"/>
                 </a:solidFill>
                 <a:latin typeface="Aptos"/>
                 <a:cs typeface="Aptos"/>
               </a:rPr>
-              <a:t>Values from 60 published sources</a:t>
+              <a:t>60 published sources</a:t>
             </a:r>
           </a:p>
           <a:p>
             <a:pPr marL="228600" indent="-228600">
+              <a:spcBef>
+                <a:spcPts val="400"/>
+              </a:spcBef>
               <a:buFont typeface="Arial"/>
               <a:buChar char="•"/>
             </a:pPr>
             <a:r>
-              <a:rPr lang="en-IN" sz="1200" b="0">
+              <a:rPr lang="en-IN" sz="1300" b="0">
                 <a:solidFill>
                   <a:srgbClr val="2D2B39"/>
                 </a:solidFill>
                 <a:latin typeface="Aptos"/>
                 <a:cs typeface="Aptos"/>
               </a:rPr>
-              <a:t>Circuit matches SPICE to 0.0001 %; 3D field matches MIT FastCap within 1 %</a:t>
+              <a:t>Checked: SPICE, FastCap</a:t>
             </a:r>
           </a:p>
           <a:p>
             <a:pPr marL="228600" indent="-228600">
+              <a:spcBef>
+                <a:spcPts val="400"/>
+              </a:spcBef>
               <a:buFont typeface="Arial"/>
               <a:buChar char="•"/>
             </a:pPr>
             <a:r>
-              <a:rPr lang="en-IN" sz="1200" b="0">
+              <a:rPr lang="en-IN" sz="1300" b="0">
                 <a:solidFill>
                   <a:srgbClr val="2D2B39"/>
                 </a:solidFill>
                 <a:latin typeface="Aptos"/>
                 <a:cs typeface="Aptos"/>
               </a:rPr>
-              <a:t>70 % of grabs over 7 body places (13 % before); 99 % of struggles</a:t>
+              <a:t>Catches 70 % of grabs</a:t>
             </a:r>
           </a:p>
           <a:p>
             <a:pPr marL="228600" indent="-228600">
+              <a:spcBef>
+                <a:spcPts val="400"/>
+              </a:spcBef>
               <a:buFont typeface="Arial"/>
               <a:buChar char="•"/>
             </a:pPr>
             <a:r>
-              <a:rPr lang="en-IN" sz="1200" b="0">
+              <a:rPr lang="en-IN" sz="1300" b="0">
                 <a:solidFill>
                   <a:srgbClr val="2D2B39"/>
                 </a:solidFill>
                 <a:latin typeface="Aptos"/>
                 <a:cs typeface="Aptos"/>
               </a:rPr>
-              <a:t>0–1 unwanted prompts in 9 simulated hours</a:t>
+              <a:t>Catches 99 % of struggles</a:t>
+            </a:r>
+          </a:p>
+          <a:p>
+            <a:pPr marL="228600" indent="-228600">
+              <a:spcBef>
+                <a:spcPts val="400"/>
+              </a:spcBef>
+              <a:buFont typeface="Arial"/>
+              <a:buChar char="•"/>
+            </a:pPr>
+            <a:r>
+              <a:rPr lang="en-IN" sz="1300" b="0">
+                <a:solidFill>
+                  <a:srgbClr val="2D2B39"/>
+                </a:solidFill>
+                <a:latin typeface="Aptos"/>
+                <a:cs typeface="Aptos"/>
+              </a:rPr>
+              <a:t>0–1 false prompts in 9 hours</a:t>
             </a:r>
           </a:p>
           <a:p>
             <a:pPr>
               <a:spcBef>
-                <a:spcPts val="900"/>
+                <a:spcPts val="1400"/>
               </a:spcBef>
               <a:buNone/>
             </a:pPr>
             <a:r>
-              <a:rPr lang="en-IN" sz="1200" b="1">
+              <a:rPr lang="en-IN" sz="1300" b="1">
                 <a:solidFill>
                   <a:srgbClr val="191B5C"/>
                 </a:solidFill>
@@ -8740,7 +8780,7 @@
               <a:buNone/>
             </a:pPr>
             <a:r>
-              <a:rPr lang="en-IN" sz="1200" b="0">
+              <a:rPr lang="en-IN" sz="1300" b="0">
                 <a:solidFill>
                   <a:srgbClr val="2D2B39"/>
                 </a:solidFill>
@@ -8870,7 +8910,7 @@
               <a:buNone/>
             </a:pPr>
             <a:r>
-              <a:rPr lang="en-IN" sz="1200" b="1">
+              <a:rPr lang="en-IN" sz="1300" b="1">
                 <a:solidFill>
                   <a:srgbClr val="191B5C"/>
                 </a:solidFill>
@@ -8882,11 +8922,14 @@
           </a:p>
           <a:p>
             <a:pPr marL="228600" indent="-228600">
+              <a:spcBef>
+                <a:spcPts val="700"/>
+              </a:spcBef>
               <a:buFont typeface="Arial"/>
               <a:buChar char="•"/>
             </a:pPr>
             <a:r>
-              <a:rPr lang="en-IN" sz="1200" b="1">
+              <a:rPr lang="en-IN" sz="1300" b="1">
                 <a:solidFill>
                   <a:srgbClr val="2D2B39"/>
                 </a:solidFill>
@@ -8896,144 +8939,188 @@
               <a:t>Moment: </a:t>
             </a:r>
             <a:r>
-              <a:rPr lang="en-IN" sz="1200" b="0">
+              <a:rPr lang="en-IN" sz="1300" b="0">
                 <a:solidFill>
                   <a:srgbClr val="2D2B39"/>
                 </a:solidFill>
                 <a:latin typeface="Aptos"/>
                 <a:cs typeface="Aptos"/>
               </a:rPr>
-              <a:t>Guard Mode on; a stranger grabs her wrist</a:t>
+              <a:t>a stranger's wrist grab</a:t>
             </a:r>
           </a:p>
           <a:p>
             <a:pPr marL="228600" indent="-228600">
+              <a:spcBef>
+                <a:spcPts val="700"/>
+              </a:spcBef>
               <a:buFont typeface="Arial"/>
               <a:buChar char="•"/>
             </a:pPr>
             <a:r>
-              <a:rPr lang="en-IN" sz="1200" b="1">
+              <a:rPr lang="en-IN" sz="1300" b="1">
                 <a:solidFill>
                   <a:srgbClr val="2D2B39"/>
                 </a:solidFill>
                 <a:latin typeface="Aptos"/>
                 <a:cs typeface="Aptos"/>
               </a:rPr>
-              <a:t>Watch face: </a:t>
-            </a:r>
-            <a:r>
-              <a:rPr lang="en-IN" sz="1200" b="0">
+              <a:t>Watch: </a:t>
+            </a:r>
+            <a:r>
+              <a:rPr lang="en-IN" sz="1300" b="0">
                 <a:solidFill>
                   <a:srgbClr val="2D2B39"/>
                 </a:solidFill>
                 <a:latin typeface="Aptos"/>
                 <a:cs typeface="Aptos"/>
               </a:rPr>
-              <a:t>asks for her PIN, 11 s of 15 left; red dot = mic recording</a:t>
+              <a:t>PIN prompt, mic on</a:t>
             </a:r>
           </a:p>
           <a:p>
             <a:pPr marL="228600" indent="-228600">
+              <a:spcBef>
+                <a:spcPts val="700"/>
+              </a:spcBef>
               <a:buFont typeface="Arial"/>
               <a:buChar char="•"/>
             </a:pPr>
             <a:r>
-              <a:rPr lang="en-IN" sz="1200" b="1">
+              <a:rPr lang="en-IN" sz="1300" b="1">
                 <a:solidFill>
                   <a:srgbClr val="2D2B39"/>
                 </a:solidFill>
                 <a:latin typeface="Aptos"/>
                 <a:cs typeface="Aptos"/>
               </a:rPr>
-              <a:t>Orange ring: </a:t>
-            </a:r>
-            <a:r>
-              <a:rPr lang="en-IN" sz="1200" b="0">
+              <a:t>Signal: </a:t>
+            </a:r>
+            <a:r>
+              <a:rPr lang="en-IN" sz="1300" b="0">
                 <a:solidFill>
                   <a:srgbClr val="2D2B39"/>
                 </a:solidFill>
                 <a:latin typeface="Aptos"/>
                 <a:cs typeface="Aptos"/>
               </a:rPr>
-              <a:t>the PIN countdown</a:t>
+              <a:t>0.1 % → 16 %</a:t>
             </a:r>
           </a:p>
           <a:p>
             <a:pPr marL="228600" indent="-228600">
+              <a:spcBef>
+                <a:spcPts val="700"/>
+              </a:spcBef>
               <a:buFont typeface="Arial"/>
               <a:buChar char="•"/>
             </a:pPr>
             <a:r>
-              <a:rPr lang="en-IN" sz="1200" b="1">
+              <a:rPr lang="en-IN" sz="1300" b="1">
                 <a:solidFill>
                   <a:srgbClr val="2D2B39"/>
                 </a:solidFill>
                 <a:latin typeface="Aptos"/>
                 <a:cs typeface="Aptos"/>
               </a:rPr>
-              <a:t>Sensor signal (log scale, last 30 s): </a:t>
-            </a:r>
-            <a:r>
-              <a:rPr lang="en-IN" sz="1200" b="0">
+              <a:t>Dashed line: </a:t>
+            </a:r>
+            <a:r>
+              <a:rPr lang="en-IN" sz="1300" b="0">
                 <a:solidFill>
                   <a:srgbClr val="2D2B39"/>
                 </a:solidFill>
                 <a:latin typeface="Aptos"/>
                 <a:cs typeface="Aptos"/>
               </a:rPr>
-              <a:t>jumps from about 0.1 % to 16 %, far above the 0.3 % touch threshold (dashed); shaded = touch felt</a:t>
+              <a:t>0.3 % touch level</a:t>
             </a:r>
           </a:p>
           <a:p>
             <a:pPr marL="228600" indent="-228600">
+              <a:spcBef>
+                <a:spcPts val="700"/>
+              </a:spcBef>
               <a:buFont typeface="Arial"/>
               <a:buChar char="•"/>
             </a:pPr>
             <a:r>
-              <a:rPr lang="en-IN" sz="1200" b="1">
+              <a:rPr lang="en-IN" sz="1300" b="1">
                 <a:solidFill>
                   <a:srgbClr val="2D2B39"/>
                 </a:solidFill>
                 <a:latin typeface="Aptos"/>
                 <a:cs typeface="Aptos"/>
               </a:rPr>
-              <a:t>Static on her body: </a:t>
-            </a:r>
-            <a:r>
-              <a:rPr lang="en-IN" sz="1200" b="0">
+              <a:t>Static: </a:t>
+            </a:r>
+            <a:r>
+              <a:rPr lang="en-IN" sz="1300" b="0">
                 <a:solidFill>
                   <a:srgbClr val="2D2B39"/>
                 </a:solidFill>
                 <a:latin typeface="Aptos"/>
                 <a:cs typeface="Aptos"/>
               </a:rPr>
-              <a:t>the red line marks the instant another body touched her (charge shared); orange ticks = arm jerks from the pull</a:t>
+              <a:t>"another body" jump</a:t>
             </a:r>
           </a:p>
           <a:p>
             <a:pPr marL="228600" indent="-228600">
+              <a:spcBef>
+                <a:spcPts val="700"/>
+              </a:spcBef>
               <a:buFont typeface="Arial"/>
               <a:buChar char="•"/>
             </a:pPr>
             <a:r>
-              <a:rPr lang="en-IN" sz="1200" b="1">
+              <a:rPr lang="en-IN" sz="1300" b="1">
                 <a:solidFill>
                   <a:srgbClr val="2D2B39"/>
                 </a:solidFill>
                 <a:latin typeface="Aptos"/>
                 <a:cs typeface="Aptos"/>
               </a:rPr>
-              <a:t>Decision: </a:t>
-            </a:r>
-            <a:r>
-              <a:rPr lang="en-IN" sz="1200" b="0">
+              <a:t>Orange ticks: </a:t>
+            </a:r>
+            <a:r>
+              <a:rPr lang="en-IN" sz="1300" b="0">
                 <a:solidFill>
                   <a:srgbClr val="2D2B39"/>
                 </a:solidFill>
                 <a:latin typeface="Aptos"/>
                 <a:cs typeface="Aptos"/>
               </a:rPr>
-              <a:t>touch held 2 s + another body = PIN prompt; no PIN in 15 s sends the alert</a:t>
+              <a:t>arm jerks</a:t>
+            </a:r>
+          </a:p>
+          <a:p>
+            <a:pPr marL="228600" indent="-228600">
+              <a:spcBef>
+                <a:spcPts val="700"/>
+              </a:spcBef>
+              <a:buFont typeface="Arial"/>
+              <a:buChar char="•"/>
+            </a:pPr>
+            <a:r>
+              <a:rPr lang="en-IN" sz="1300" b="1">
+                <a:solidFill>
+                  <a:srgbClr val="2D2B39"/>
+                </a:solidFill>
+                <a:latin typeface="Aptos"/>
+                <a:cs typeface="Aptos"/>
+              </a:rPr>
+              <a:t>No PIN in 15 s: </a:t>
+            </a:r>
+            <a:r>
+              <a:rPr lang="en-IN" sz="1300" b="0">
+                <a:solidFill>
+                  <a:srgbClr val="2D2B39"/>
+                </a:solidFill>
+                <a:latin typeface="Aptos"/>
+                <a:cs typeface="Aptos"/>
+              </a:rPr>
+              <a:t>alert sent</a:t>
             </a:r>
           </a:p>
         </p:txBody>

</xml_diff>

<commit_message>
Deck slide 6: feasibility qualities, market examples and risk/mitigation as bullets
</commit_message>
<xml_diff>
--- a/docs/SparshaGuard_BIH2026.pptx
+++ b/docs/SparshaGuard_BIH2026.pptx
@@ -9616,7 +9616,7 @@
         <p:spPr>
           <a:xfrm>
             <a:off x="640080" y="1737360"/>
-            <a:ext cx="3520440" cy="1600200"/>
+            <a:ext cx="3520440" cy="2286000"/>
           </a:xfrm>
           <a:prstGeom prst="roundRect">
             <a:avLst/>
@@ -9662,7 +9662,7 @@
         <p:spPr>
           <a:xfrm>
             <a:off x="640080" y="1737360"/>
-            <a:ext cx="68580" cy="1600200"/>
+            <a:ext cx="68580" cy="2286000"/>
           </a:xfrm>
           <a:prstGeom prst="rect">
             <a:avLst/>
@@ -9743,7 +9743,7 @@
         <p:spPr>
           <a:xfrm>
             <a:off x="822959" y="2212848"/>
-            <a:ext cx="3200400" cy="1033271"/>
+            <a:ext cx="3200400" cy="1766000"/>
           </a:xfrm>
           <a:prstGeom prst="rect">
             <a:avLst/>
@@ -9756,15 +9756,148 @@
           </a:bodyPr>
           <a:lstStyle/>
           <a:p>
-            <a:pPr algn="l"/>
-            <a:r>
-              <a:rPr sz="1400" b="0">
+            <a:pPr marL="228600" indent="-228600">
+              <a:spcBef>
+                <a:spcPts val="300"/>
+              </a:spcBef>
+              <a:buFont typeface="Arial"/>
+              <a:buChar char="•"/>
+            </a:pPr>
+            <a:r>
+              <a:rPr lang="en-IN" sz="1300" b="1">
                 <a:solidFill>
                   <a:srgbClr val="2D2B39"/>
                 </a:solidFill>
                 <a:latin typeface="Aptos"/>
-              </a:rPr>
-              <a:t>Off-the-shelf parts: ESP32, LC tank, electrode, ADS1115, motion sensor, heart-rate sensor, mic. Detection logic is written and tested.</a:t>
+                <a:cs typeface="Aptos"/>
+              </a:rPr>
+              <a:t>Effective: </a:t>
+            </a:r>
+            <a:r>
+              <a:rPr lang="en-IN" sz="1300" b="0">
+                <a:solidFill>
+                  <a:srgbClr val="2D2B39"/>
+                </a:solidFill>
+                <a:latin typeface="Aptos"/>
+                <a:cs typeface="Aptos"/>
+              </a:rPr>
+              <a:t>70 % of grabs caught</a:t>
+            </a:r>
+          </a:p>
+          <a:p>
+            <a:pPr marL="228600" indent="-228600">
+              <a:spcBef>
+                <a:spcPts val="300"/>
+              </a:spcBef>
+              <a:buFont typeface="Arial"/>
+              <a:buChar char="•"/>
+            </a:pPr>
+            <a:r>
+              <a:rPr lang="en-IN" sz="1300" b="1">
+                <a:solidFill>
+                  <a:srgbClr val="2D2B39"/>
+                </a:solidFill>
+                <a:latin typeface="Aptos"/>
+                <a:cs typeface="Aptos"/>
+              </a:rPr>
+              <a:t>Usable: </a:t>
+            </a:r>
+            <a:r>
+              <a:rPr lang="en-IN" sz="1300" b="0">
+                <a:solidFill>
+                  <a:srgbClr val="2D2B39"/>
+                </a:solidFill>
+                <a:latin typeface="Aptos"/>
+                <a:cs typeface="Aptos"/>
+              </a:rPr>
+              <a:t>hands-free, PIN to cancel</a:t>
+            </a:r>
+          </a:p>
+          <a:p>
+            <a:pPr marL="228600" indent="-228600">
+              <a:spcBef>
+                <a:spcPts val="300"/>
+              </a:spcBef>
+              <a:buFont typeface="Arial"/>
+              <a:buChar char="•"/>
+            </a:pPr>
+            <a:r>
+              <a:rPr lang="en-IN" sz="1300" b="1">
+                <a:solidFill>
+                  <a:srgbClr val="2D2B39"/>
+                </a:solidFill>
+                <a:latin typeface="Aptos"/>
+                <a:cs typeface="Aptos"/>
+              </a:rPr>
+              <a:t>Efficient: </a:t>
+            </a:r>
+            <a:r>
+              <a:rPr lang="en-IN" sz="1300" b="0">
+                <a:solidFill>
+                  <a:srgbClr val="2D2B39"/>
+                </a:solidFill>
+                <a:latin typeface="Aptos"/>
+                <a:cs typeface="Aptos"/>
+              </a:rPr>
+              <a:t>all on-watch, on battery</a:t>
+            </a:r>
+          </a:p>
+          <a:p>
+            <a:pPr marL="228600" indent="-228600">
+              <a:spcBef>
+                <a:spcPts val="300"/>
+              </a:spcBef>
+              <a:buFont typeface="Arial"/>
+              <a:buChar char="•"/>
+            </a:pPr>
+            <a:r>
+              <a:rPr lang="en-IN" sz="1300" b="1">
+                <a:solidFill>
+                  <a:srgbClr val="2D2B39"/>
+                </a:solidFill>
+                <a:latin typeface="Aptos"/>
+                <a:cs typeface="Aptos"/>
+              </a:rPr>
+              <a:t>Reliable: </a:t>
+            </a:r>
+            <a:r>
+              <a:rPr lang="en-IN" sz="1300" b="0">
+                <a:solidFill>
+                  <a:srgbClr val="2D2B39"/>
+                </a:solidFill>
+                <a:latin typeface="Aptos"/>
+                <a:cs typeface="Aptos"/>
+              </a:rPr>
+              <a:t>0–1 false alarms in 9 h</a:t>
+            </a:r>
+          </a:p>
+          <a:p>
+            <a:pPr marL="228600" indent="-228600">
+              <a:spcBef>
+                <a:spcPts val="300"/>
+              </a:spcBef>
+              <a:buFont typeface="Arial"/>
+              <a:buChar char="•"/>
+            </a:pPr>
+            <a:r>
+              <a:rPr lang="en-IN" sz="1300" b="1">
+                <a:solidFill>
+                  <a:srgbClr val="2D2B39"/>
+                </a:solidFill>
+                <a:latin typeface="Aptos"/>
+                <a:cs typeface="Aptos"/>
+              </a:rPr>
+              <a:t>Trustworthy: </a:t>
+            </a:r>
+            <a:r>
+              <a:rPr lang="en-IN" sz="1300" b="0">
+                <a:solidFill>
+                  <a:srgbClr val="2D2B39"/>
+                </a:solidFill>
+                <a:latin typeface="Aptos"/>
+                <a:cs typeface="Aptos"/>
+              </a:rPr>
+              <a:t>60 cited sources</a:t>
             </a:r>
           </a:p>
         </p:txBody>
@@ -9778,7 +9911,7 @@
         <p:spPr>
           <a:xfrm>
             <a:off x="4343400" y="1737360"/>
-            <a:ext cx="3520440" cy="1600200"/>
+            <a:ext cx="3520440" cy="2286000"/>
           </a:xfrm>
           <a:prstGeom prst="roundRect">
             <a:avLst/>
@@ -9824,7 +9957,7 @@
         <p:spPr>
           <a:xfrm>
             <a:off x="4343400" y="1737360"/>
-            <a:ext cx="68580" cy="1600200"/>
+            <a:ext cx="68580" cy="2286000"/>
           </a:xfrm>
           <a:prstGeom prst="rect">
             <a:avLst/>
@@ -9905,7 +10038,7 @@
         <p:spPr>
           <a:xfrm>
             <a:off x="4526280" y="2212848"/>
-            <a:ext cx="3200400" cy="1033271"/>
+            <a:ext cx="3200400" cy="1766000"/>
           </a:xfrm>
           <a:prstGeom prst="rect">
             <a:avLst/>
@@ -9918,15 +10051,41 @@
           </a:bodyPr>
           <a:lstStyle/>
           <a:p>
-            <a:pPr algn="l"/>
-            <a:r>
-              <a:rPr sz="1400" b="0">
+            <a:pPr marL="228600" indent="-228600">
+              <a:spcBef>
+                <a:spcPts val="300"/>
+              </a:spcBef>
+              <a:buFont typeface="Arial"/>
+              <a:buChar char="•"/>
+            </a:pPr>
+            <a:r>
+              <a:rPr lang="en-IN" sz="1300" b="0">
                 <a:solidFill>
                   <a:srgbClr val="2D2B39"/>
                 </a:solidFill>
                 <a:latin typeface="Aptos"/>
-              </a:rPr>
-              <a:t>Battery-powered; all decisions on the watch. Alerts over 4G LTE Cat-1, since 2G is being shut down.</a:t>
+                <a:cs typeface="Aptos"/>
+              </a:rPr>
+              <a:t>Battery-powered; all decisions on the watch</a:t>
+            </a:r>
+          </a:p>
+          <a:p>
+            <a:pPr marL="228600" indent="-228600">
+              <a:spcBef>
+                <a:spcPts val="300"/>
+              </a:spcBef>
+              <a:buFont typeface="Arial"/>
+              <a:buChar char="•"/>
+            </a:pPr>
+            <a:r>
+              <a:rPr lang="en-IN" sz="1300" b="0">
+                <a:solidFill>
+                  <a:srgbClr val="2D2B39"/>
+                </a:solidFill>
+                <a:latin typeface="Aptos"/>
+                <a:cs typeface="Aptos"/>
+              </a:rPr>
+              <a:t>Alerts over 4G LTE Cat-1 (2G is being shut down)</a:t>
             </a:r>
           </a:p>
         </p:txBody>
@@ -9940,7 +10099,7 @@
         <p:spPr>
           <a:xfrm>
             <a:off x="8046720" y="1737360"/>
-            <a:ext cx="3520440" cy="1600200"/>
+            <a:ext cx="3520440" cy="2286000"/>
           </a:xfrm>
           <a:prstGeom prst="roundRect">
             <a:avLst/>
@@ -9986,7 +10145,7 @@
         <p:spPr>
           <a:xfrm>
             <a:off x="8046720" y="1737360"/>
-            <a:ext cx="68580" cy="1600200"/>
+            <a:ext cx="68580" cy="2286000"/>
           </a:xfrm>
           <a:prstGeom prst="rect">
             <a:avLst/>
@@ -10067,7 +10226,7 @@
         <p:spPr>
           <a:xfrm>
             <a:off x="8229600" y="2212848"/>
-            <a:ext cx="3200400" cy="1033271"/>
+            <a:ext cx="3200400" cy="1766000"/>
           </a:xfrm>
           <a:prstGeom prst="rect">
             <a:avLst/>
@@ -10080,15 +10239,79 @@
           </a:bodyPr>
           <a:lstStyle/>
           <a:p>
-            <a:pPr algn="l"/>
-            <a:r>
-              <a:rPr sz="1400" b="0">
+            <a:pPr marL="228600" indent="-228600">
+              <a:spcBef>
+                <a:spcPts val="300"/>
+              </a:spcBef>
+              <a:buFont typeface="Arial"/>
+              <a:buChar char="•"/>
+            </a:pPr>
+            <a:r>
+              <a:rPr lang="en-IN" sz="1300" b="0">
                 <a:solidFill>
                   <a:srgbClr val="2D2B39"/>
                 </a:solidFill>
                 <a:latin typeface="Aptos"/>
-              </a:rPr>
-              <a:t>Women commuters, students, night-shift workers and their families. Unlike SOS apps, she needs no action.</a:t>
+                <a:cs typeface="Aptos"/>
+              </a:rPr>
+              <a:t>Women commuters: bus, metro, cab</a:t>
+            </a:r>
+          </a:p>
+          <a:p>
+            <a:pPr marL="228600" indent="-228600">
+              <a:spcBef>
+                <a:spcPts val="300"/>
+              </a:spcBef>
+              <a:buFont typeface="Arial"/>
+              <a:buChar char="•"/>
+            </a:pPr>
+            <a:r>
+              <a:rPr lang="en-IN" sz="1300" b="0">
+                <a:solidFill>
+                  <a:srgbClr val="2D2B39"/>
+                </a:solidFill>
+                <a:latin typeface="Aptos"/>
+                <a:cs typeface="Aptos"/>
+              </a:rPr>
+              <a:t>Students, night-shift workers</a:t>
+            </a:r>
+          </a:p>
+          <a:p>
+            <a:pPr marL="228600" indent="-228600">
+              <a:spcBef>
+                <a:spcPts val="300"/>
+              </a:spcBef>
+              <a:buFont typeface="Arial"/>
+              <a:buChar char="•"/>
+            </a:pPr>
+            <a:r>
+              <a:rPr lang="en-IN" sz="1300" b="0">
+                <a:solidFill>
+                  <a:srgbClr val="2D2B39"/>
+                </a:solidFill>
+                <a:latin typeface="Aptos"/>
+                <a:cs typeface="Aptos"/>
+              </a:rPr>
+              <a:t>Families wanting peace of mind</a:t>
+            </a:r>
+          </a:p>
+          <a:p>
+            <a:pPr marL="228600" indent="-228600">
+              <a:spcBef>
+                <a:spcPts val="300"/>
+              </a:spcBef>
+              <a:buFont typeface="Arial"/>
+              <a:buChar char="•"/>
+            </a:pPr>
+            <a:r>
+              <a:rPr lang="en-IN" sz="1300" b="0">
+                <a:solidFill>
+                  <a:srgbClr val="2D2B39"/>
+                </a:solidFill>
+                <a:latin typeface="Aptos"/>
+                <a:cs typeface="Aptos"/>
+              </a:rPr>
+              <a:t>Edge: no SOS button to press</a:t>
             </a:r>
           </a:p>
         </p:txBody>
@@ -10101,8 +10324,8 @@
         </p:nvSpPr>
         <p:spPr>
           <a:xfrm>
-            <a:off x="640080" y="3703320"/>
-            <a:ext cx="5349240" cy="1554480"/>
+            <a:off x="640080" y="4343400"/>
+            <a:ext cx="5349240" cy="1645920"/>
           </a:xfrm>
           <a:prstGeom prst="roundRect">
             <a:avLst/>
@@ -10147,8 +10370,8 @@
         </p:nvSpPr>
         <p:spPr>
           <a:xfrm>
-            <a:off x="640080" y="3703320"/>
-            <a:ext cx="68580" cy="1554480"/>
+            <a:off x="640080" y="4343400"/>
+            <a:ext cx="68580" cy="1645920"/>
           </a:xfrm>
           <a:prstGeom prst="rect">
             <a:avLst/>
@@ -10193,7 +10416,7 @@
         </p:nvSpPr>
         <p:spPr>
           <a:xfrm>
-            <a:off x="822959" y="3813048"/>
+            <a:off x="822959" y="4453128"/>
             <a:ext cx="5029200" cy="320040"/>
           </a:xfrm>
           <a:prstGeom prst="rect">
@@ -10228,7 +10451,7 @@
         </p:nvSpPr>
         <p:spPr>
           <a:xfrm>
-            <a:off x="822959" y="4178808"/>
+            <a:off x="822959" y="4818888"/>
             <a:ext cx="5029200" cy="987552"/>
           </a:xfrm>
           <a:prstGeom prst="rect">
@@ -10242,15 +10465,60 @@
           </a:bodyPr>
           <a:lstStyle/>
           <a:p>
-            <a:pPr algn="l"/>
-            <a:r>
-              <a:rPr sz="1400" b="0">
+            <a:pPr marL="228600" indent="-228600">
+              <a:spcBef>
+                <a:spcPts val="300"/>
+              </a:spcBef>
+              <a:buFont typeface="Arial"/>
+              <a:buChar char="•"/>
+            </a:pPr>
+            <a:r>
+              <a:rPr lang="en-IN" sz="1300" b="0">
                 <a:solidFill>
                   <a:srgbClr val="2D2B39"/>
                 </a:solidFill>
                 <a:latin typeface="Aptos"/>
-              </a:rPr>
-              <a:t>Simulated, not yet measured. Static charge on Indian floors and struggle-motion thresholds are estimates; a grab that only holds can be missed.</a:t>
+                <a:cs typeface="Aptos"/>
+              </a:rPr>
+              <a:t>Simulated, not yet measured on hardware</a:t>
+            </a:r>
+          </a:p>
+          <a:p>
+            <a:pPr marL="228600" indent="-228600">
+              <a:spcBef>
+                <a:spcPts val="300"/>
+              </a:spcBef>
+              <a:buFont typeface="Arial"/>
+              <a:buChar char="•"/>
+            </a:pPr>
+            <a:r>
+              <a:rPr lang="en-IN" sz="1300" b="0">
+                <a:solidFill>
+                  <a:srgbClr val="2D2B39"/>
+                </a:solidFill>
+                <a:latin typeface="Aptos"/>
+                <a:cs typeface="Aptos"/>
+              </a:rPr>
+              <a:t>Static charge on Indian floors and struggle thresholds are estimates</a:t>
+            </a:r>
+          </a:p>
+          <a:p>
+            <a:pPr marL="228600" indent="-228600">
+              <a:spcBef>
+                <a:spcPts val="300"/>
+              </a:spcBef>
+              <a:buFont typeface="Arial"/>
+              <a:buChar char="•"/>
+            </a:pPr>
+            <a:r>
+              <a:rPr lang="en-IN" sz="1300" b="0">
+                <a:solidFill>
+                  <a:srgbClr val="2D2B39"/>
+                </a:solidFill>
+                <a:latin typeface="Aptos"/>
+                <a:cs typeface="Aptos"/>
+              </a:rPr>
+              <a:t>A grab that only holds, away from the wrist, can be missed</a:t>
             </a:r>
           </a:p>
         </p:txBody>
@@ -10263,8 +10531,8 @@
         </p:nvSpPr>
         <p:spPr>
           <a:xfrm>
-            <a:off x="6217920" y="3703320"/>
-            <a:ext cx="5349240" cy="1554480"/>
+            <a:off x="6217920" y="4343400"/>
+            <a:ext cx="5349240" cy="1645920"/>
           </a:xfrm>
           <a:prstGeom prst="roundRect">
             <a:avLst/>
@@ -10309,8 +10577,8 @@
         </p:nvSpPr>
         <p:spPr>
           <a:xfrm>
-            <a:off x="6217920" y="3703320"/>
-            <a:ext cx="68580" cy="1554480"/>
+            <a:off x="6217920" y="4343400"/>
+            <a:ext cx="68580" cy="1645920"/>
           </a:xfrm>
           <a:prstGeom prst="rect">
             <a:avLst/>
@@ -10355,7 +10623,7 @@
         </p:nvSpPr>
         <p:spPr>
           <a:xfrm>
-            <a:off x="6400800" y="3813048"/>
+            <a:off x="6400800" y="4453128"/>
             <a:ext cx="5029200" cy="320040"/>
           </a:xfrm>
           <a:prstGeom prst="rect">
@@ -10390,7 +10658,7 @@
         </p:nvSpPr>
         <p:spPr>
           <a:xfrm>
-            <a:off x="6400800" y="4178808"/>
+            <a:off x="6400800" y="4818888"/>
             <a:ext cx="5029200" cy="987552"/>
           </a:xfrm>
           <a:prstGeom prst="rect">
@@ -10404,15 +10672,60 @@
           </a:bodyPr>
           <a:lstStyle/>
           <a:p>
-            <a:pPr algn="l"/>
-            <a:r>
-              <a:rPr sz="1400" b="0">
+            <a:pPr marL="228600" indent="-228600">
+              <a:spcBef>
+                <a:spcPts val="300"/>
+              </a:spcBef>
+              <a:buFont typeface="Arial"/>
+              <a:buChar char="•"/>
+            </a:pPr>
+            <a:r>
+              <a:rPr lang="en-IN" sz="1300" b="0">
                 <a:solidFill>
                   <a:srgbClr val="2D2B39"/>
                 </a:solidFill>
                 <a:latin typeface="Aptos"/>
-              </a:rPr>
-              <a:t>A battery prototype (Gate 1) measures body voltages and staged-struggle motion. The wrist sweep still catches wrist grabs; the PIN handles friendly touches.</a:t>
+                <a:cs typeface="Aptos"/>
+              </a:rPr>
+              <a:t>Gate 1 battery prototype measures body voltages and staged struggles</a:t>
+            </a:r>
+          </a:p>
+          <a:p>
+            <a:pPr marL="228600" indent="-228600">
+              <a:spcBef>
+                <a:spcPts val="300"/>
+              </a:spcBef>
+              <a:buFont typeface="Arial"/>
+              <a:buChar char="•"/>
+            </a:pPr>
+            <a:r>
+              <a:rPr lang="en-IN" sz="1300" b="0">
+                <a:solidFill>
+                  <a:srgbClr val="2D2B39"/>
+                </a:solidFill>
+                <a:latin typeface="Aptos"/>
+                <a:cs typeface="Aptos"/>
+              </a:rPr>
+              <a:t>The wrist sensor still catches wrist grabs on its own</a:t>
+            </a:r>
+          </a:p>
+          <a:p>
+            <a:pPr marL="228600" indent="-228600">
+              <a:spcBef>
+                <a:spcPts val="300"/>
+              </a:spcBef>
+              <a:buFont typeface="Arial"/>
+              <a:buChar char="•"/>
+            </a:pPr>
+            <a:r>
+              <a:rPr lang="en-IN" sz="1300" b="0">
+                <a:solidFill>
+                  <a:srgbClr val="2D2B39"/>
+                </a:solidFill>
+                <a:latin typeface="Aptos"/>
+                <a:cs typeface="Aptos"/>
+              </a:rPr>
+              <a:t>The PIN settles friendly touches</a:t>
             </a:r>
           </a:p>
         </p:txBody>

</xml_diff>

<commit_message>
Deck slide 7: impact and business model as bullets; success metrics as goal-vs-simulation bars
</commit_message>
<xml_diff>
--- a/docs/SparshaGuard_BIH2026.pptx
+++ b/docs/SparshaGuard_BIH2026.pptx
@@ -11116,7 +11116,7 @@
         <p:spPr>
           <a:xfrm>
             <a:off x="640080" y="1737360"/>
-            <a:ext cx="3520440" cy="1737360"/>
+            <a:ext cx="3520440" cy="2560320"/>
           </a:xfrm>
           <a:prstGeom prst="roundRect">
             <a:avLst/>
@@ -11162,7 +11162,7 @@
         <p:spPr>
           <a:xfrm>
             <a:off x="640080" y="1737360"/>
-            <a:ext cx="68580" cy="1737360"/>
+            <a:ext cx="68580" cy="2560320"/>
           </a:xfrm>
           <a:prstGeom prst="rect">
             <a:avLst/>
@@ -11243,7 +11243,7 @@
         <p:spPr>
           <a:xfrm>
             <a:off x="822959" y="2212848"/>
-            <a:ext cx="3200400" cy="1170431"/>
+            <a:ext cx="3200400" cy="2040320"/>
           </a:xfrm>
           <a:prstGeom prst="rect">
             <a:avLst/>
@@ -11256,15 +11256,60 @@
           </a:bodyPr>
           <a:lstStyle/>
           <a:p>
-            <a:pPr algn="l"/>
-            <a:r>
-              <a:rPr sz="1400" b="0">
+            <a:pPr marL="228600" indent="-228600">
+              <a:spcBef>
+                <a:spcPts val="400"/>
+              </a:spcBef>
+              <a:buFont typeface="Arial"/>
+              <a:buChar char="•"/>
+            </a:pPr>
+            <a:r>
+              <a:rPr lang="en-IN" sz="1300" b="0">
                 <a:solidFill>
                   <a:srgbClr val="2D2B39"/>
                 </a:solidFill>
                 <a:latin typeface="Aptos"/>
-              </a:rPr>
-              <a:t>Help is called even when she can't reach her phone. Live location and audio give family and police something to act on.</a:t>
+                <a:cs typeface="Aptos"/>
+              </a:rPr>
+              <a:t>Help is called even when she can't reach her phone</a:t>
+            </a:r>
+          </a:p>
+          <a:p>
+            <a:pPr marL="228600" indent="-228600">
+              <a:spcBef>
+                <a:spcPts val="400"/>
+              </a:spcBef>
+              <a:buFont typeface="Arial"/>
+              <a:buChar char="•"/>
+            </a:pPr>
+            <a:r>
+              <a:rPr lang="en-IN" sz="1300" b="0">
+                <a:solidFill>
+                  <a:srgbClr val="2D2B39"/>
+                </a:solidFill>
+                <a:latin typeface="Aptos"/>
+                <a:cs typeface="Aptos"/>
+              </a:rPr>
+              <a:t>Family and police get her live location and a voice recording</a:t>
+            </a:r>
+          </a:p>
+          <a:p>
+            <a:pPr marL="228600" indent="-228600">
+              <a:spcBef>
+                <a:spcPts val="400"/>
+              </a:spcBef>
+              <a:buFont typeface="Arial"/>
+              <a:buChar char="•"/>
+            </a:pPr>
+            <a:r>
+              <a:rPr lang="en-IN" sz="1300" b="0">
+                <a:solidFill>
+                  <a:srgbClr val="2D2B39"/>
+                </a:solidFill>
+                <a:latin typeface="Aptos"/>
+                <a:cs typeface="Aptos"/>
+              </a:rPr>
+              <a:t>Forced to cancel? The duress PIN still alerts silently</a:t>
             </a:r>
           </a:p>
         </p:txBody>
@@ -11278,7 +11323,7 @@
         <p:spPr>
           <a:xfrm>
             <a:off x="4343400" y="1737360"/>
-            <a:ext cx="3520440" cy="1737360"/>
+            <a:ext cx="3520440" cy="2560320"/>
           </a:xfrm>
           <a:prstGeom prst="roundRect">
             <a:avLst/>
@@ -11324,7 +11369,7 @@
         <p:spPr>
           <a:xfrm>
             <a:off x="4343400" y="1737360"/>
-            <a:ext cx="68580" cy="1737360"/>
+            <a:ext cx="68580" cy="2560320"/>
           </a:xfrm>
           <a:prstGeom prst="rect">
             <a:avLst/>
@@ -11405,7 +11450,7 @@
         <p:spPr>
           <a:xfrm>
             <a:off x="4526280" y="2212848"/>
-            <a:ext cx="3200400" cy="1170431"/>
+            <a:ext cx="3200400" cy="2040320"/>
           </a:xfrm>
           <a:prstGeom prst="rect">
             <a:avLst/>
@@ -11418,15 +11463,60 @@
           </a:bodyPr>
           <a:lstStyle/>
           <a:p>
-            <a:pPr algn="l"/>
-            <a:r>
-              <a:rPr sz="1400" b="0">
+            <a:pPr marL="228600" indent="-228600">
+              <a:spcBef>
+                <a:spcPts val="400"/>
+              </a:spcBef>
+              <a:buFont typeface="Arial"/>
+              <a:buChar char="•"/>
+            </a:pPr>
+            <a:r>
+              <a:rPr lang="en-IN" sz="1300" b="0">
                 <a:solidFill>
                   <a:srgbClr val="2D2B39"/>
                 </a:solidFill>
                 <a:latin typeface="Aptos"/>
-              </a:rPr>
-              <a:t>Watch sold to individuals; bulk plans for colleges, hostels and employers; optional alert-service subscription.</a:t>
+                <a:cs typeface="Aptos"/>
+              </a:rPr>
+              <a:t>Watch sold to individuals</a:t>
+            </a:r>
+          </a:p>
+          <a:p>
+            <a:pPr marL="228600" indent="-228600">
+              <a:spcBef>
+                <a:spcPts val="400"/>
+              </a:spcBef>
+              <a:buFont typeface="Arial"/>
+              <a:buChar char="•"/>
+            </a:pPr>
+            <a:r>
+              <a:rPr lang="en-IN" sz="1300" b="0">
+                <a:solidFill>
+                  <a:srgbClr val="2D2B39"/>
+                </a:solidFill>
+                <a:latin typeface="Aptos"/>
+                <a:cs typeface="Aptos"/>
+              </a:rPr>
+              <a:t>Bulk plans for colleges, hostels and employers</a:t>
+            </a:r>
+          </a:p>
+          <a:p>
+            <a:pPr marL="228600" indent="-228600">
+              <a:spcBef>
+                <a:spcPts val="400"/>
+              </a:spcBef>
+              <a:buFont typeface="Arial"/>
+              <a:buChar char="•"/>
+            </a:pPr>
+            <a:r>
+              <a:rPr lang="en-IN" sz="1300" b="0">
+                <a:solidFill>
+                  <a:srgbClr val="2D2B39"/>
+                </a:solidFill>
+                <a:latin typeface="Aptos"/>
+                <a:cs typeface="Aptos"/>
+              </a:rPr>
+              <a:t>Alert-service subscription</a:t>
             </a:r>
           </a:p>
         </p:txBody>
@@ -11440,7 +11530,7 @@
         <p:spPr>
           <a:xfrm>
             <a:off x="8046720" y="1737360"/>
-            <a:ext cx="3520440" cy="1737360"/>
+            <a:ext cx="3520440" cy="2560320"/>
           </a:xfrm>
           <a:prstGeom prst="roundRect">
             <a:avLst/>
@@ -11486,7 +11576,7 @@
         <p:spPr>
           <a:xfrm>
             <a:off x="8046720" y="1737360"/>
-            <a:ext cx="68580" cy="1737360"/>
+            <a:ext cx="68580" cy="2560320"/>
           </a:xfrm>
           <a:prstGeom prst="rect">
             <a:avLst/>
@@ -11560,48 +11650,13 @@
       </p:sp>
       <p:sp>
         <p:nvSpPr>
-          <p:cNvPr id="22" name="TextBox 21"/>
-          <p:cNvSpPr txBox="1"/>
-          <p:nvPr/>
-        </p:nvSpPr>
-        <p:spPr>
-          <a:xfrm>
-            <a:off x="8229600" y="2212848"/>
-            <a:ext cx="3200400" cy="1170431"/>
-          </a:xfrm>
-          <a:prstGeom prst="rect">
-            <a:avLst/>
-          </a:prstGeom>
-          <a:noFill/>
-        </p:spPr>
-        <p:txBody>
-          <a:bodyPr wrap="square" lIns="54864" tIns="18288" rIns="54864" bIns="18288" anchor="t">
-            <a:spAutoFit/>
-          </a:bodyPr>
-          <a:lstStyle/>
-          <a:p>
-            <a:pPr algn="l"/>
-            <a:r>
-              <a:rPr sz="1400" b="0">
-                <a:solidFill>
-                  <a:srgbClr val="2D2B39"/>
-                </a:solidFill>
-                <a:latin typeface="Aptos"/>
-              </a:rPr>
-              <a:t>≥ 90 % of wrist grabs and ≥ 60 % anywhere on hardware · &lt; 1 unwanted prompt a day · alert within 20 s</a:t>
-            </a:r>
-          </a:p>
-        </p:txBody>
-      </p:sp>
-      <p:sp>
-        <p:nvSpPr>
           <p:cNvPr id="23" name="TextBox 22"/>
           <p:cNvSpPr txBox="1"/>
           <p:nvPr/>
         </p:nvSpPr>
         <p:spPr>
           <a:xfrm>
-            <a:off x="685800" y="3977639"/>
+            <a:off x="685800" y="4434839"/>
             <a:ext cx="3657600" cy="320040"/>
           </a:xfrm>
           <a:prstGeom prst="rect">
@@ -11636,7 +11691,7 @@
         </p:nvSpPr>
         <p:spPr>
           <a:xfrm>
-            <a:off x="685800" y="4480560"/>
+            <a:off x="685800" y="4937760"/>
             <a:ext cx="3474720" cy="960120"/>
           </a:xfrm>
           <a:prstGeom prst="roundRect">
@@ -11682,7 +11737,7 @@
         </p:nvSpPr>
         <p:spPr>
           <a:xfrm>
-            <a:off x="822960" y="4590288"/>
+            <a:off x="822960" y="5047488"/>
             <a:ext cx="777240" cy="274320"/>
           </a:xfrm>
           <a:prstGeom prst="rect">
@@ -11717,7 +11772,7 @@
         </p:nvSpPr>
         <p:spPr>
           <a:xfrm>
-            <a:off x="1600200" y="4572000"/>
+            <a:off x="1600200" y="5029200"/>
             <a:ext cx="2377440" cy="502920"/>
           </a:xfrm>
           <a:prstGeom prst="rect">
@@ -11752,7 +11807,7 @@
         </p:nvSpPr>
         <p:spPr>
           <a:xfrm>
-            <a:off x="4480560" y="4480560"/>
+            <a:off x="4480560" y="4937760"/>
             <a:ext cx="3474720" cy="960120"/>
           </a:xfrm>
           <a:prstGeom prst="roundRect">
@@ -11798,7 +11853,7 @@
         </p:nvSpPr>
         <p:spPr>
           <a:xfrm>
-            <a:off x="4617720" y="4590288"/>
+            <a:off x="4617720" y="5047488"/>
             <a:ext cx="777240" cy="274320"/>
           </a:xfrm>
           <a:prstGeom prst="rect">
@@ -11833,7 +11888,7 @@
         </p:nvSpPr>
         <p:spPr>
           <a:xfrm>
-            <a:off x="5394960" y="4572000"/>
+            <a:off x="5394960" y="5029200"/>
             <a:ext cx="2377440" cy="502920"/>
           </a:xfrm>
           <a:prstGeom prst="rect">
@@ -11868,7 +11923,7 @@
         </p:nvSpPr>
         <p:spPr>
           <a:xfrm>
-            <a:off x="8275320" y="4480560"/>
+            <a:off x="8275320" y="4937760"/>
             <a:ext cx="3474720" cy="960120"/>
           </a:xfrm>
           <a:prstGeom prst="roundRect">
@@ -11914,7 +11969,7 @@
         </p:nvSpPr>
         <p:spPr>
           <a:xfrm>
-            <a:off x="8412480" y="4590288"/>
+            <a:off x="8412480" y="5047488"/>
             <a:ext cx="777240" cy="274320"/>
           </a:xfrm>
           <a:prstGeom prst="rect">
@@ -11949,7 +12004,7 @@
         </p:nvSpPr>
         <p:spPr>
           <a:xfrm>
-            <a:off x="9189720" y="4572000"/>
+            <a:off x="9189720" y="5029200"/>
             <a:ext cx="2377440" cy="502920"/>
           </a:xfrm>
           <a:prstGeom prst="rect">
@@ -12007,6 +12062,691 @@
           </a:prstGeom>
         </p:spPr>
       </p:pic>
+      <p:sp>
+        <p:nvSpPr>
+          <p:cNvPr id="35" name="TextBox 34"/>
+          <p:cNvSpPr txBox="1"/>
+          <p:nvPr/>
+        </p:nvSpPr>
+        <p:spPr>
+          <a:xfrm>
+            <a:off x="8229600" y="2170000"/>
+            <a:ext cx="3200400" cy="200000"/>
+          </a:xfrm>
+          <a:prstGeom prst="rect">
+            <a:avLst/>
+          </a:prstGeom>
+          <a:noFill/>
+        </p:spPr>
+        <p:txBody>
+          <a:bodyPr wrap="square" lIns="0" rIns="0" tIns="0" bIns="0" anchor="ctr">
+            <a:spAutoFit/>
+          </a:bodyPr>
+          <a:lstStyle/>
+          <a:p>
+            <a:pPr algn="l"/>
+            <a:r>
+              <a:rPr sz="1000" b="0">
+                <a:solidFill>
+                  <a:srgbClr val="6B6A78"/>
+                </a:solidFill>
+                <a:latin typeface="Aptos"/>
+              </a:rPr>
+              <a:t>Bar = today's simulation   </a:t>
+            </a:r>
+            <a:r>
+              <a:rPr sz="1100" b="1">
+                <a:solidFill>
+                  <a:srgbClr val="5B2278"/>
+                </a:solidFill>
+                <a:latin typeface="Aptos"/>
+              </a:rPr>
+              <a:t>|</a:t>
+            </a:r>
+            <a:r>
+              <a:rPr sz="1000" b="0">
+                <a:solidFill>
+                  <a:srgbClr val="6B6A78"/>
+                </a:solidFill>
+                <a:latin typeface="Aptos"/>
+              </a:rPr>
+              <a:t> = Gate 1 goal</a:t>
+            </a:r>
+          </a:p>
+        </p:txBody>
+      </p:sp>
+      <p:sp>
+        <p:nvSpPr>
+          <p:cNvPr id="36" name="TextBox 35"/>
+          <p:cNvSpPr txBox="1"/>
+          <p:nvPr/>
+        </p:nvSpPr>
+        <p:spPr>
+          <a:xfrm>
+            <a:off x="8229600" y="2430000"/>
+            <a:ext cx="1700400" cy="220000"/>
+          </a:xfrm>
+          <a:prstGeom prst="rect">
+            <a:avLst/>
+          </a:prstGeom>
+          <a:noFill/>
+        </p:spPr>
+        <p:txBody>
+          <a:bodyPr wrap="square" lIns="0" rIns="0" tIns="0" bIns="0" anchor="ctr">
+            <a:spAutoFit/>
+          </a:bodyPr>
+          <a:lstStyle/>
+          <a:p>
+            <a:pPr algn="l"/>
+            <a:r>
+              <a:rPr sz="1200" b="1">
+                <a:solidFill>
+                  <a:srgbClr val="2D2B39"/>
+                </a:solidFill>
+                <a:latin typeface="Aptos"/>
+              </a:rPr>
+              <a:t>Wrist grabs caught</a:t>
+            </a:r>
+          </a:p>
+        </p:txBody>
+      </p:sp>
+      <p:sp>
+        <p:nvSpPr>
+          <p:cNvPr id="37" name="TextBox 36"/>
+          <p:cNvSpPr txBox="1"/>
+          <p:nvPr/>
+        </p:nvSpPr>
+        <p:spPr>
+          <a:xfrm>
+            <a:off x="9930000" y="2430000"/>
+            <a:ext cx="1500000" cy="220000"/>
+          </a:xfrm>
+          <a:prstGeom prst="rect">
+            <a:avLst/>
+          </a:prstGeom>
+          <a:noFill/>
+        </p:spPr>
+        <p:txBody>
+          <a:bodyPr wrap="square" lIns="0" rIns="0" tIns="0" bIns="0" anchor="ctr">
+            <a:spAutoFit/>
+          </a:bodyPr>
+          <a:lstStyle/>
+          <a:p>
+            <a:pPr algn="r"/>
+            <a:r>
+              <a:rPr sz="1200" b="1">
+                <a:solidFill>
+                  <a:srgbClr val="191B5C"/>
+                </a:solidFill>
+                <a:latin typeface="Aptos"/>
+              </a:rPr>
+              <a:t>99 %</a:t>
+            </a:r>
+            <a:r>
+              <a:rPr sz="1000" b="0">
+                <a:solidFill>
+                  <a:srgbClr val="6B6A78"/>
+                </a:solidFill>
+                <a:latin typeface="Aptos"/>
+              </a:rPr>
+              <a:t>  (goal 90 %)</a:t>
+            </a:r>
+          </a:p>
+        </p:txBody>
+      </p:sp>
+      <p:sp>
+        <p:nvSpPr>
+          <p:cNvPr id="38" name="Rectangle 37"/>
+          <p:cNvSpPr/>
+          <p:nvPr/>
+        </p:nvSpPr>
+        <p:spPr>
+          <a:xfrm>
+            <a:off x="8229600" y="2675000"/>
+            <a:ext cx="3200400" cy="100000"/>
+          </a:xfrm>
+          <a:prstGeom prst="rect">
+            <a:avLst/>
+          </a:prstGeom>
+          <a:solidFill>
+            <a:srgbClr val="E6E6EE"/>
+          </a:solidFill>
+          <a:ln>
+            <a:noFill/>
+          </a:ln>
+          <a:effectLst/>
+        </p:spPr>
+        <p:style>
+          <a:lnRef idx="1">
+            <a:schemeClr val="accent1"/>
+          </a:lnRef>
+          <a:fillRef idx="3">
+            <a:schemeClr val="accent1"/>
+          </a:fillRef>
+          <a:effectRef idx="2">
+            <a:schemeClr val="accent1"/>
+          </a:effectRef>
+          <a:fontRef idx="minor">
+            <a:schemeClr val="lt1"/>
+          </a:fontRef>
+        </p:style>
+        <p:txBody>
+          <a:bodyPr rtlCol="0" anchor="ctr"/>
+          <a:lstStyle/>
+          <a:p>
+            <a:pPr algn="ctr"/>
+          </a:p>
+        </p:txBody>
+      </p:sp>
+      <p:sp>
+        <p:nvSpPr>
+          <p:cNvPr id="39" name="Rectangle 38"/>
+          <p:cNvSpPr/>
+          <p:nvPr/>
+        </p:nvSpPr>
+        <p:spPr>
+          <a:xfrm>
+            <a:off x="8229600" y="2675000"/>
+            <a:ext cx="3168396" cy="100000"/>
+          </a:xfrm>
+          <a:prstGeom prst="rect">
+            <a:avLst/>
+          </a:prstGeom>
+          <a:solidFill>
+            <a:srgbClr val="191B5C"/>
+          </a:solidFill>
+          <a:ln>
+            <a:noFill/>
+          </a:ln>
+          <a:effectLst/>
+        </p:spPr>
+        <p:style>
+          <a:lnRef idx="1">
+            <a:schemeClr val="accent1"/>
+          </a:lnRef>
+          <a:fillRef idx="3">
+            <a:schemeClr val="accent1"/>
+          </a:fillRef>
+          <a:effectRef idx="2">
+            <a:schemeClr val="accent1"/>
+          </a:effectRef>
+          <a:fontRef idx="minor">
+            <a:schemeClr val="lt1"/>
+          </a:fontRef>
+        </p:style>
+        <p:txBody>
+          <a:bodyPr rtlCol="0" anchor="ctr"/>
+          <a:lstStyle/>
+          <a:p>
+            <a:pPr algn="ctr"/>
+          </a:p>
+        </p:txBody>
+      </p:sp>
+      <p:sp>
+        <p:nvSpPr>
+          <p:cNvPr id="40" name="Rectangle 39"/>
+          <p:cNvSpPr/>
+          <p:nvPr/>
+        </p:nvSpPr>
+        <p:spPr>
+          <a:xfrm>
+            <a:off x="11095960" y="2630000"/>
+            <a:ext cx="28000" cy="190000"/>
+          </a:xfrm>
+          <a:prstGeom prst="rect">
+            <a:avLst/>
+          </a:prstGeom>
+          <a:solidFill>
+            <a:srgbClr val="5B2278"/>
+          </a:solidFill>
+          <a:ln>
+            <a:noFill/>
+          </a:ln>
+          <a:effectLst/>
+        </p:spPr>
+        <p:style>
+          <a:lnRef idx="1">
+            <a:schemeClr val="accent1"/>
+          </a:lnRef>
+          <a:fillRef idx="3">
+            <a:schemeClr val="accent1"/>
+          </a:fillRef>
+          <a:effectRef idx="2">
+            <a:schemeClr val="accent1"/>
+          </a:effectRef>
+          <a:fontRef idx="minor">
+            <a:schemeClr val="lt1"/>
+          </a:fontRef>
+        </p:style>
+        <p:txBody>
+          <a:bodyPr rtlCol="0" anchor="ctr"/>
+          <a:lstStyle/>
+          <a:p>
+            <a:pPr algn="ctr"/>
+          </a:p>
+        </p:txBody>
+      </p:sp>
+      <p:sp>
+        <p:nvSpPr>
+          <p:cNvPr id="41" name="TextBox 40"/>
+          <p:cNvSpPr txBox="1"/>
+          <p:nvPr/>
+        </p:nvSpPr>
+        <p:spPr>
+          <a:xfrm>
+            <a:off x="8229600" y="2870000"/>
+            <a:ext cx="1700400" cy="220000"/>
+          </a:xfrm>
+          <a:prstGeom prst="rect">
+            <a:avLst/>
+          </a:prstGeom>
+          <a:noFill/>
+        </p:spPr>
+        <p:txBody>
+          <a:bodyPr wrap="square" lIns="0" rIns="0" tIns="0" bIns="0" anchor="ctr">
+            <a:spAutoFit/>
+          </a:bodyPr>
+          <a:lstStyle/>
+          <a:p>
+            <a:pPr algn="l"/>
+            <a:r>
+              <a:rPr sz="1200" b="1">
+                <a:solidFill>
+                  <a:srgbClr val="2D2B39"/>
+                </a:solidFill>
+                <a:latin typeface="Aptos"/>
+              </a:rPr>
+              <a:t>Grabs anywhere</a:t>
+            </a:r>
+          </a:p>
+        </p:txBody>
+      </p:sp>
+      <p:sp>
+        <p:nvSpPr>
+          <p:cNvPr id="42" name="TextBox 41"/>
+          <p:cNvSpPr txBox="1"/>
+          <p:nvPr/>
+        </p:nvSpPr>
+        <p:spPr>
+          <a:xfrm>
+            <a:off x="9930000" y="2870000"/>
+            <a:ext cx="1500000" cy="220000"/>
+          </a:xfrm>
+          <a:prstGeom prst="rect">
+            <a:avLst/>
+          </a:prstGeom>
+          <a:noFill/>
+        </p:spPr>
+        <p:txBody>
+          <a:bodyPr wrap="square" lIns="0" rIns="0" tIns="0" bIns="0" anchor="ctr">
+            <a:spAutoFit/>
+          </a:bodyPr>
+          <a:lstStyle/>
+          <a:p>
+            <a:pPr algn="r"/>
+            <a:r>
+              <a:rPr sz="1200" b="1">
+                <a:solidFill>
+                  <a:srgbClr val="191B5C"/>
+                </a:solidFill>
+                <a:latin typeface="Aptos"/>
+              </a:rPr>
+              <a:t>70 %</a:t>
+            </a:r>
+            <a:r>
+              <a:rPr sz="1000" b="0">
+                <a:solidFill>
+                  <a:srgbClr val="6B6A78"/>
+                </a:solidFill>
+                <a:latin typeface="Aptos"/>
+              </a:rPr>
+              <a:t>  (goal 60 %)</a:t>
+            </a:r>
+          </a:p>
+        </p:txBody>
+      </p:sp>
+      <p:sp>
+        <p:nvSpPr>
+          <p:cNvPr id="43" name="Rectangle 42"/>
+          <p:cNvSpPr/>
+          <p:nvPr/>
+        </p:nvSpPr>
+        <p:spPr>
+          <a:xfrm>
+            <a:off x="8229600" y="3115000"/>
+            <a:ext cx="3200400" cy="100000"/>
+          </a:xfrm>
+          <a:prstGeom prst="rect">
+            <a:avLst/>
+          </a:prstGeom>
+          <a:solidFill>
+            <a:srgbClr val="E6E6EE"/>
+          </a:solidFill>
+          <a:ln>
+            <a:noFill/>
+          </a:ln>
+          <a:effectLst/>
+        </p:spPr>
+        <p:style>
+          <a:lnRef idx="1">
+            <a:schemeClr val="accent1"/>
+          </a:lnRef>
+          <a:fillRef idx="3">
+            <a:schemeClr val="accent1"/>
+          </a:fillRef>
+          <a:effectRef idx="2">
+            <a:schemeClr val="accent1"/>
+          </a:effectRef>
+          <a:fontRef idx="minor">
+            <a:schemeClr val="lt1"/>
+          </a:fontRef>
+        </p:style>
+        <p:txBody>
+          <a:bodyPr rtlCol="0" anchor="ctr"/>
+          <a:lstStyle/>
+          <a:p>
+            <a:pPr algn="ctr"/>
+          </a:p>
+        </p:txBody>
+      </p:sp>
+      <p:sp>
+        <p:nvSpPr>
+          <p:cNvPr id="44" name="Rectangle 43"/>
+          <p:cNvSpPr/>
+          <p:nvPr/>
+        </p:nvSpPr>
+        <p:spPr>
+          <a:xfrm>
+            <a:off x="8229600" y="3115000"/>
+            <a:ext cx="2240280" cy="100000"/>
+          </a:xfrm>
+          <a:prstGeom prst="rect">
+            <a:avLst/>
+          </a:prstGeom>
+          <a:solidFill>
+            <a:srgbClr val="191B5C"/>
+          </a:solidFill>
+          <a:ln>
+            <a:noFill/>
+          </a:ln>
+          <a:effectLst/>
+        </p:spPr>
+        <p:style>
+          <a:lnRef idx="1">
+            <a:schemeClr val="accent1"/>
+          </a:lnRef>
+          <a:fillRef idx="3">
+            <a:schemeClr val="accent1"/>
+          </a:fillRef>
+          <a:effectRef idx="2">
+            <a:schemeClr val="accent1"/>
+          </a:effectRef>
+          <a:fontRef idx="minor">
+            <a:schemeClr val="lt1"/>
+          </a:fontRef>
+        </p:style>
+        <p:txBody>
+          <a:bodyPr rtlCol="0" anchor="ctr"/>
+          <a:lstStyle/>
+          <a:p>
+            <a:pPr algn="ctr"/>
+          </a:p>
+        </p:txBody>
+      </p:sp>
+      <p:sp>
+        <p:nvSpPr>
+          <p:cNvPr id="45" name="Rectangle 44"/>
+          <p:cNvSpPr/>
+          <p:nvPr/>
+        </p:nvSpPr>
+        <p:spPr>
+          <a:xfrm>
+            <a:off x="10135840" y="3070000"/>
+            <a:ext cx="28000" cy="190000"/>
+          </a:xfrm>
+          <a:prstGeom prst="rect">
+            <a:avLst/>
+          </a:prstGeom>
+          <a:solidFill>
+            <a:srgbClr val="5B2278"/>
+          </a:solidFill>
+          <a:ln>
+            <a:noFill/>
+          </a:ln>
+          <a:effectLst/>
+        </p:spPr>
+        <p:style>
+          <a:lnRef idx="1">
+            <a:schemeClr val="accent1"/>
+          </a:lnRef>
+          <a:fillRef idx="3">
+            <a:schemeClr val="accent1"/>
+          </a:fillRef>
+          <a:effectRef idx="2">
+            <a:schemeClr val="accent1"/>
+          </a:effectRef>
+          <a:fontRef idx="minor">
+            <a:schemeClr val="lt1"/>
+          </a:fontRef>
+        </p:style>
+        <p:txBody>
+          <a:bodyPr rtlCol="0" anchor="ctr"/>
+          <a:lstStyle/>
+          <a:p>
+            <a:pPr algn="ctr"/>
+          </a:p>
+        </p:txBody>
+      </p:sp>
+      <p:sp>
+        <p:nvSpPr>
+          <p:cNvPr id="46" name="TextBox 45"/>
+          <p:cNvSpPr txBox="1"/>
+          <p:nvPr/>
+        </p:nvSpPr>
+        <p:spPr>
+          <a:xfrm>
+            <a:off x="8229600" y="3330000"/>
+            <a:ext cx="1500400" cy="220000"/>
+          </a:xfrm>
+          <a:prstGeom prst="rect">
+            <a:avLst/>
+          </a:prstGeom>
+          <a:noFill/>
+        </p:spPr>
+        <p:txBody>
+          <a:bodyPr wrap="square" lIns="0" rIns="0" tIns="0" bIns="0" anchor="ctr">
+            <a:spAutoFit/>
+          </a:bodyPr>
+          <a:lstStyle/>
+          <a:p>
+            <a:pPr algn="l"/>
+            <a:r>
+              <a:rPr sz="1200" b="1">
+                <a:solidFill>
+                  <a:srgbClr val="2D2B39"/>
+                </a:solidFill>
+                <a:latin typeface="Aptos"/>
+              </a:rPr>
+              <a:t>Unwanted prompts</a:t>
+            </a:r>
+          </a:p>
+        </p:txBody>
+      </p:sp>
+      <p:sp>
+        <p:nvSpPr>
+          <p:cNvPr id="47" name="TextBox 46"/>
+          <p:cNvSpPr txBox="1"/>
+          <p:nvPr/>
+        </p:nvSpPr>
+        <p:spPr>
+          <a:xfrm>
+            <a:off x="9730000" y="3330000"/>
+            <a:ext cx="1700000" cy="220000"/>
+          </a:xfrm>
+          <a:prstGeom prst="rect">
+            <a:avLst/>
+          </a:prstGeom>
+          <a:noFill/>
+        </p:spPr>
+        <p:txBody>
+          <a:bodyPr wrap="square" lIns="0" rIns="0" tIns="0" bIns="0" anchor="ctr">
+            <a:spAutoFit/>
+          </a:bodyPr>
+          <a:lstStyle/>
+          <a:p>
+            <a:pPr algn="r"/>
+            <a:r>
+              <a:rPr sz="1200" b="1">
+                <a:solidFill>
+                  <a:srgbClr val="191B5C"/>
+                </a:solidFill>
+                <a:latin typeface="Aptos"/>
+              </a:rPr>
+              <a:t>0–1 in 9 h</a:t>
+            </a:r>
+          </a:p>
+        </p:txBody>
+      </p:sp>
+      <p:sp>
+        <p:nvSpPr>
+          <p:cNvPr id="48" name="TextBox 47"/>
+          <p:cNvSpPr txBox="1"/>
+          <p:nvPr/>
+        </p:nvSpPr>
+        <p:spPr>
+          <a:xfrm>
+            <a:off x="8229600" y="3530000"/>
+            <a:ext cx="3200400" cy="180000"/>
+          </a:xfrm>
+          <a:prstGeom prst="rect">
+            <a:avLst/>
+          </a:prstGeom>
+          <a:noFill/>
+        </p:spPr>
+        <p:txBody>
+          <a:bodyPr wrap="square" lIns="0" rIns="0" tIns="0" bIns="0" anchor="ctr">
+            <a:spAutoFit/>
+          </a:bodyPr>
+          <a:lstStyle/>
+          <a:p>
+            <a:pPr algn="l"/>
+            <a:r>
+              <a:rPr sz="1000" b="0">
+                <a:solidFill>
+                  <a:srgbClr val="6B6A78"/>
+                </a:solidFill>
+                <a:latin typeface="Aptos"/>
+              </a:rPr>
+              <a:t>goal &lt; 1 a day</a:t>
+            </a:r>
+          </a:p>
+        </p:txBody>
+      </p:sp>
+      <p:sp>
+        <p:nvSpPr>
+          <p:cNvPr id="49" name="TextBox 48"/>
+          <p:cNvSpPr txBox="1"/>
+          <p:nvPr/>
+        </p:nvSpPr>
+        <p:spPr>
+          <a:xfrm>
+            <a:off x="8229600" y="3730000"/>
+            <a:ext cx="1500400" cy="220000"/>
+          </a:xfrm>
+          <a:prstGeom prst="rect">
+            <a:avLst/>
+          </a:prstGeom>
+          <a:noFill/>
+        </p:spPr>
+        <p:txBody>
+          <a:bodyPr wrap="square" lIns="0" rIns="0" tIns="0" bIns="0" anchor="ctr">
+            <a:spAutoFit/>
+          </a:bodyPr>
+          <a:lstStyle/>
+          <a:p>
+            <a:pPr algn="l"/>
+            <a:r>
+              <a:rPr sz="1200" b="1">
+                <a:solidFill>
+                  <a:srgbClr val="2D2B39"/>
+                </a:solidFill>
+                <a:latin typeface="Aptos"/>
+              </a:rPr>
+              <a:t>Alert sent</a:t>
+            </a:r>
+          </a:p>
+        </p:txBody>
+      </p:sp>
+      <p:sp>
+        <p:nvSpPr>
+          <p:cNvPr id="50" name="TextBox 49"/>
+          <p:cNvSpPr txBox="1"/>
+          <p:nvPr/>
+        </p:nvSpPr>
+        <p:spPr>
+          <a:xfrm>
+            <a:off x="9730000" y="3730000"/>
+            <a:ext cx="1700000" cy="220000"/>
+          </a:xfrm>
+          <a:prstGeom prst="rect">
+            <a:avLst/>
+          </a:prstGeom>
+          <a:noFill/>
+        </p:spPr>
+        <p:txBody>
+          <a:bodyPr wrap="square" lIns="0" rIns="0" tIns="0" bIns="0" anchor="ctr">
+            <a:spAutoFit/>
+          </a:bodyPr>
+          <a:lstStyle/>
+          <a:p>
+            <a:pPr algn="r"/>
+            <a:r>
+              <a:rPr sz="1200" b="1">
+                <a:solidFill>
+                  <a:srgbClr val="191B5C"/>
+                </a:solidFill>
+                <a:latin typeface="Aptos"/>
+              </a:rPr>
+              <a:t>after the 15 s PIN</a:t>
+            </a:r>
+          </a:p>
+        </p:txBody>
+      </p:sp>
+      <p:sp>
+        <p:nvSpPr>
+          <p:cNvPr id="51" name="TextBox 50"/>
+          <p:cNvSpPr txBox="1"/>
+          <p:nvPr/>
+        </p:nvSpPr>
+        <p:spPr>
+          <a:xfrm>
+            <a:off x="8229600" y="3930000"/>
+            <a:ext cx="3200400" cy="180000"/>
+          </a:xfrm>
+          <a:prstGeom prst="rect">
+            <a:avLst/>
+          </a:prstGeom>
+          <a:noFill/>
+        </p:spPr>
+        <p:txBody>
+          <a:bodyPr wrap="square" lIns="0" rIns="0" tIns="0" bIns="0" anchor="ctr">
+            <a:spAutoFit/>
+          </a:bodyPr>
+          <a:lstStyle/>
+          <a:p>
+            <a:pPr algn="l"/>
+            <a:r>
+              <a:rPr sz="1000" b="0">
+                <a:solidFill>
+                  <a:srgbClr val="6B6A78"/>
+                </a:solidFill>
+                <a:latin typeface="Aptos"/>
+              </a:rPr>
+              <a:t>goal ≤ 20 s</a:t>
+            </a:r>
+          </a:p>
+        </p:txBody>
+      </p:sp>
     </p:spTree>
   </p:cSld>
   <p:clrMapOvr>

</xml_diff>

<commit_message>
Deck slide 5: two twin screenshots, a stranger's grab detected and her own hand ignored
</commit_message>
<xml_diff>
--- a/docs/SparshaGuard_BIH2026.pptx
+++ b/docs/SparshaGuard_BIH2026.pptx
@@ -8801,7 +8801,7 @@
         <p:spPr>
           <a:xfrm>
             <a:off x="4161800" y="1737360"/>
-            <a:ext cx="3276000" cy="4297680"/>
+            <a:ext cx="3579820" cy="4297680"/>
           </a:xfrm>
           <a:prstGeom prst="roundRect">
             <a:avLst/>
@@ -8886,255 +8886,14 @@
       </p:sp>
       <p:sp>
         <p:nvSpPr>
-          <p:cNvPr id="18" name="TextBox 17"/>
-          <p:cNvSpPr txBox="1"/>
-          <p:nvPr/>
-        </p:nvSpPr>
-        <p:spPr>
-          <a:xfrm>
-            <a:off x="4344680" y="1847088"/>
-            <a:ext cx="2930240" cy="4097680"/>
-          </a:xfrm>
-          <a:prstGeom prst="rect">
-            <a:avLst/>
-          </a:prstGeom>
-          <a:noFill/>
-        </p:spPr>
-        <p:txBody>
-          <a:bodyPr wrap="square" lIns="54864" tIns="18288" rIns="54864" bIns="18288" anchor="t">
-            <a:spAutoFit/>
-          </a:bodyPr>
-          <a:lstStyle/>
-          <a:p>
-            <a:pPr>
-              <a:buNone/>
-            </a:pPr>
-            <a:r>
-              <a:rPr lang="en-IN" sz="1300" b="1">
-                <a:solidFill>
-                  <a:srgbClr val="191B5C"/>
-                </a:solidFill>
-                <a:latin typeface="Aptos"/>
-                <a:cs typeface="Aptos"/>
-              </a:rPr>
-              <a:t>What the screenshot shows</a:t>
-            </a:r>
-          </a:p>
-          <a:p>
-            <a:pPr marL="228600" indent="-228600">
-              <a:spcBef>
-                <a:spcPts val="700"/>
-              </a:spcBef>
-              <a:buFont typeface="Arial"/>
-              <a:buChar char="•"/>
-            </a:pPr>
-            <a:r>
-              <a:rPr lang="en-IN" sz="1300" b="1">
-                <a:solidFill>
-                  <a:srgbClr val="2D2B39"/>
-                </a:solidFill>
-                <a:latin typeface="Aptos"/>
-                <a:cs typeface="Aptos"/>
-              </a:rPr>
-              <a:t>Moment: </a:t>
-            </a:r>
-            <a:r>
-              <a:rPr lang="en-IN" sz="1300" b="0">
-                <a:solidFill>
-                  <a:srgbClr val="2D2B39"/>
-                </a:solidFill>
-                <a:latin typeface="Aptos"/>
-                <a:cs typeface="Aptos"/>
-              </a:rPr>
-              <a:t>a stranger's wrist grab</a:t>
-            </a:r>
-          </a:p>
-          <a:p>
-            <a:pPr marL="228600" indent="-228600">
-              <a:spcBef>
-                <a:spcPts val="700"/>
-              </a:spcBef>
-              <a:buFont typeface="Arial"/>
-              <a:buChar char="•"/>
-            </a:pPr>
-            <a:r>
-              <a:rPr lang="en-IN" sz="1300" b="1">
-                <a:solidFill>
-                  <a:srgbClr val="2D2B39"/>
-                </a:solidFill>
-                <a:latin typeface="Aptos"/>
-                <a:cs typeface="Aptos"/>
-              </a:rPr>
-              <a:t>Watch: </a:t>
-            </a:r>
-            <a:r>
-              <a:rPr lang="en-IN" sz="1300" b="0">
-                <a:solidFill>
-                  <a:srgbClr val="2D2B39"/>
-                </a:solidFill>
-                <a:latin typeface="Aptos"/>
-                <a:cs typeface="Aptos"/>
-              </a:rPr>
-              <a:t>PIN prompt, mic on</a:t>
-            </a:r>
-          </a:p>
-          <a:p>
-            <a:pPr marL="228600" indent="-228600">
-              <a:spcBef>
-                <a:spcPts val="700"/>
-              </a:spcBef>
-              <a:buFont typeface="Arial"/>
-              <a:buChar char="•"/>
-            </a:pPr>
-            <a:r>
-              <a:rPr lang="en-IN" sz="1300" b="1">
-                <a:solidFill>
-                  <a:srgbClr val="2D2B39"/>
-                </a:solidFill>
-                <a:latin typeface="Aptos"/>
-                <a:cs typeface="Aptos"/>
-              </a:rPr>
-              <a:t>Signal: </a:t>
-            </a:r>
-            <a:r>
-              <a:rPr lang="en-IN" sz="1300" b="0">
-                <a:solidFill>
-                  <a:srgbClr val="2D2B39"/>
-                </a:solidFill>
-                <a:latin typeface="Aptos"/>
-                <a:cs typeface="Aptos"/>
-              </a:rPr>
-              <a:t>0.1 % → 16 %</a:t>
-            </a:r>
-          </a:p>
-          <a:p>
-            <a:pPr marL="228600" indent="-228600">
-              <a:spcBef>
-                <a:spcPts val="700"/>
-              </a:spcBef>
-              <a:buFont typeface="Arial"/>
-              <a:buChar char="•"/>
-            </a:pPr>
-            <a:r>
-              <a:rPr lang="en-IN" sz="1300" b="1">
-                <a:solidFill>
-                  <a:srgbClr val="2D2B39"/>
-                </a:solidFill>
-                <a:latin typeface="Aptos"/>
-                <a:cs typeface="Aptos"/>
-              </a:rPr>
-              <a:t>Dashed line: </a:t>
-            </a:r>
-            <a:r>
-              <a:rPr lang="en-IN" sz="1300" b="0">
-                <a:solidFill>
-                  <a:srgbClr val="2D2B39"/>
-                </a:solidFill>
-                <a:latin typeface="Aptos"/>
-                <a:cs typeface="Aptos"/>
-              </a:rPr>
-              <a:t>0.3 % touch level</a:t>
-            </a:r>
-          </a:p>
-          <a:p>
-            <a:pPr marL="228600" indent="-228600">
-              <a:spcBef>
-                <a:spcPts val="700"/>
-              </a:spcBef>
-              <a:buFont typeface="Arial"/>
-              <a:buChar char="•"/>
-            </a:pPr>
-            <a:r>
-              <a:rPr lang="en-IN" sz="1300" b="1">
-                <a:solidFill>
-                  <a:srgbClr val="2D2B39"/>
-                </a:solidFill>
-                <a:latin typeface="Aptos"/>
-                <a:cs typeface="Aptos"/>
-              </a:rPr>
-              <a:t>Static: </a:t>
-            </a:r>
-            <a:r>
-              <a:rPr lang="en-IN" sz="1300" b="0">
-                <a:solidFill>
-                  <a:srgbClr val="2D2B39"/>
-                </a:solidFill>
-                <a:latin typeface="Aptos"/>
-                <a:cs typeface="Aptos"/>
-              </a:rPr>
-              <a:t>"another body" jump</a:t>
-            </a:r>
-          </a:p>
-          <a:p>
-            <a:pPr marL="228600" indent="-228600">
-              <a:spcBef>
-                <a:spcPts val="700"/>
-              </a:spcBef>
-              <a:buFont typeface="Arial"/>
-              <a:buChar char="•"/>
-            </a:pPr>
-            <a:r>
-              <a:rPr lang="en-IN" sz="1300" b="1">
-                <a:solidFill>
-                  <a:srgbClr val="2D2B39"/>
-                </a:solidFill>
-                <a:latin typeface="Aptos"/>
-                <a:cs typeface="Aptos"/>
-              </a:rPr>
-              <a:t>Orange ticks: </a:t>
-            </a:r>
-            <a:r>
-              <a:rPr lang="en-IN" sz="1300" b="0">
-                <a:solidFill>
-                  <a:srgbClr val="2D2B39"/>
-                </a:solidFill>
-                <a:latin typeface="Aptos"/>
-                <a:cs typeface="Aptos"/>
-              </a:rPr>
-              <a:t>arm jerks</a:t>
-            </a:r>
-          </a:p>
-          <a:p>
-            <a:pPr marL="228600" indent="-228600">
-              <a:spcBef>
-                <a:spcPts val="700"/>
-              </a:spcBef>
-              <a:buFont typeface="Arial"/>
-              <a:buChar char="•"/>
-            </a:pPr>
-            <a:r>
-              <a:rPr lang="en-IN" sz="1300" b="1">
-                <a:solidFill>
-                  <a:srgbClr val="2D2B39"/>
-                </a:solidFill>
-                <a:latin typeface="Aptos"/>
-                <a:cs typeface="Aptos"/>
-              </a:rPr>
-              <a:t>No PIN in 15 s: </a:t>
-            </a:r>
-            <a:r>
-              <a:rPr lang="en-IN" sz="1300" b="0">
-                <a:solidFill>
-                  <a:srgbClr val="2D2B39"/>
-                </a:solidFill>
-                <a:latin typeface="Aptos"/>
-                <a:cs typeface="Aptos"/>
-              </a:rPr>
-              <a:t>alert sent</a:t>
-            </a:r>
-          </a:p>
-        </p:txBody>
-      </p:sp>
-      <p:sp>
-        <p:nvSpPr>
           <p:cNvPr id="19" name="Rounded Rectangle 18"/>
           <p:cNvSpPr/>
           <p:nvPr/>
         </p:nvSpPr>
         <p:spPr>
           <a:xfrm>
-            <a:off x="7637800" y="1737360"/>
-            <a:ext cx="3883640" cy="4297680"/>
+            <a:off x="7941620" y="1737360"/>
+            <a:ext cx="3579820" cy="4297680"/>
           </a:xfrm>
           <a:prstGeom prst="roundRect">
             <a:avLst/>
@@ -9179,8 +8938,8 @@
         </p:nvSpPr>
         <p:spPr>
           <a:xfrm>
-            <a:off x="7820680" y="1797360"/>
-            <a:ext cx="3517880" cy="320040"/>
+            <a:off x="4344680" y="1797360"/>
+            <a:ext cx="3214060" cy="320040"/>
           </a:xfrm>
           <a:prstGeom prst="rect">
             <a:avLst/>
@@ -9201,7 +8960,42 @@
                 </a:solidFill>
                 <a:latin typeface="Aptos"/>
               </a:rPr>
-              <a:t>SCREENSHOT · DIGITAL TWIN</a:t>
+              <a:t>DETECTED · A STRANGER'S GRAB</a:t>
+            </a:r>
+          </a:p>
+        </p:txBody>
+      </p:sp>
+      <p:sp>
+        <p:nvSpPr>
+          <p:cNvPr id="20" name="TextBox 19"/>
+          <p:cNvSpPr txBox="1"/>
+          <p:nvPr/>
+        </p:nvSpPr>
+        <p:spPr>
+          <a:xfrm>
+            <a:off x="8124500" y="1797360"/>
+            <a:ext cx="3214060" cy="320040"/>
+          </a:xfrm>
+          <a:prstGeom prst="rect">
+            <a:avLst/>
+          </a:prstGeom>
+          <a:noFill/>
+        </p:spPr>
+        <p:txBody>
+          <a:bodyPr wrap="square" lIns="54864" tIns="18288" rIns="54864" bIns="18288" anchor="ctr">
+            <a:spAutoFit/>
+          </a:bodyPr>
+          <a:lstStyle/>
+          <a:p>
+            <a:pPr algn="ctr"/>
+            <a:r>
+              <a:rPr sz="1300" b="1">
+                <a:solidFill>
+                  <a:srgbClr val="191B5C"/>
+                </a:solidFill>
+                <a:latin typeface="Aptos"/>
+              </a:rPr>
+              <a:t>IGNORED · HER OWN HAND</a:t>
             </a:r>
           </a:p>
         </p:txBody>
@@ -9253,8 +9047,32 @@
         </p:blipFill>
         <p:spPr>
           <a:xfrm>
-            <a:off x="7776491" y="2067360"/>
-            <a:ext cx="3606258" cy="3747680"/>
+            <a:off x="4281800" y="2067360"/>
+            <a:ext cx="3339820" cy="3470793"/>
+          </a:xfrm>
+          <a:prstGeom prst="rect">
+            <a:avLst/>
+          </a:prstGeom>
+        </p:spPr>
+      </p:pic>
+      <p:pic>
+        <p:nvPicPr>
+          <p:cNvPr id="27" name="Demo screenshot" descr="self_shot.png"/>
+          <p:cNvPicPr>
+            <a:picLocks noChangeAspect="1"/>
+          </p:cNvPicPr>
+          <p:nvPr/>
+        </p:nvPicPr>
+        <p:blipFill>
+          <a:blip r:embed="rId5"/>
+          <a:stretch>
+            <a:fillRect/>
+          </a:stretch>
+        </p:blipFill>
+        <p:spPr>
+          <a:xfrm>
+            <a:off x="8061620" y="2067360"/>
+            <a:ext cx="3339820" cy="3470793"/>
           </a:xfrm>
           <a:prstGeom prst="rect">
             <a:avLst/>

</xml_diff>

<commit_message>
Deck slide 5: normal PIN and duress PIN screenshots (watch + contact's phone)
</commit_message>
<xml_diff>
--- a/docs/SparshaGuard_BIH2026.pptx
+++ b/docs/SparshaGuard_BIH2026.pptx
@@ -8960,7 +8960,7 @@
                 </a:solidFill>
                 <a:latin typeface="Aptos"/>
               </a:rPr>
-              <a:t>DETECTED · A STRANGER'S GRAB</a:t>
+              <a:t>NORMAL PIN · 1234</a:t>
             </a:r>
           </a:p>
         </p:txBody>
@@ -8995,7 +8995,7 @@
                 </a:solidFill>
                 <a:latin typeface="Aptos"/>
               </a:rPr>
-              <a:t>IGNORED · HER OWN HAND</a:t>
+              <a:t>DURESS PIN · 9999</a:t>
             </a:r>
           </a:p>
         </p:txBody>
@@ -9033,7 +9033,7 @@
       </p:pic>
       <p:pic>
         <p:nvPicPr>
-          <p:cNvPr id="26" name="Demo screenshot" descr="s5_shot.png"/>
+          <p:cNvPr id="26" name="Demo screenshot" descr="pin_normal.png"/>
           <p:cNvPicPr>
             <a:picLocks noChangeAspect="1"/>
           </p:cNvPicPr>
@@ -9047,17 +9047,52 @@
         </p:blipFill>
         <p:spPr>
           <a:xfrm>
-            <a:off x="4281800" y="2067360"/>
-            <a:ext cx="3339820" cy="3470793"/>
+            <a:off x="4281800" y="2097360"/>
+            <a:ext cx="3339820" cy="3120701"/>
           </a:xfrm>
           <a:prstGeom prst="rect">
             <a:avLst/>
           </a:prstGeom>
         </p:spPr>
       </p:pic>
+      <p:sp>
+        <p:nvSpPr>
+          <p:cNvPr id="27" name="TextBox 26"/>
+          <p:cNvSpPr txBox="1"/>
+          <p:nvPr/>
+        </p:nvSpPr>
+        <p:spPr>
+          <a:xfrm>
+            <a:off x="4344680" y="5308061"/>
+            <a:ext cx="3214060" cy="300000"/>
+          </a:xfrm>
+          <a:prstGeom prst="rect">
+            <a:avLst/>
+          </a:prstGeom>
+          <a:noFill/>
+        </p:spPr>
+        <p:txBody>
+          <a:bodyPr wrap="square">
+            <a:spAutoFit/>
+          </a:bodyPr>
+          <a:lstStyle/>
+          <a:p>
+            <a:pPr algn="ctr"/>
+            <a:r>
+              <a:rPr sz="1300" b="1">
+                <a:solidFill>
+                  <a:srgbClr val="2D2B39"/>
+                </a:solidFill>
+                <a:latin typeface="Aptos"/>
+              </a:rPr>
+              <a:t>Cancelled · no alert sent</a:t>
+            </a:r>
+          </a:p>
+        </p:txBody>
+      </p:sp>
       <p:pic>
         <p:nvPicPr>
-          <p:cNvPr id="27" name="Demo screenshot" descr="self_shot.png"/>
+          <p:cNvPr id="28" name="Demo screenshot" descr="pin_duress.png"/>
           <p:cNvPicPr>
             <a:picLocks noChangeAspect="1"/>
           </p:cNvPicPr>
@@ -9071,14 +9106,49 @@
         </p:blipFill>
         <p:spPr>
           <a:xfrm>
-            <a:off x="8061620" y="2067360"/>
-            <a:ext cx="3339820" cy="3470793"/>
+            <a:off x="8061620" y="2097360"/>
+            <a:ext cx="3339820" cy="3120701"/>
           </a:xfrm>
           <a:prstGeom prst="rect">
             <a:avLst/>
           </a:prstGeom>
         </p:spPr>
       </p:pic>
+      <p:sp>
+        <p:nvSpPr>
+          <p:cNvPr id="29" name="TextBox 28"/>
+          <p:cNvSpPr txBox="1"/>
+          <p:nvPr/>
+        </p:nvSpPr>
+        <p:spPr>
+          <a:xfrm>
+            <a:off x="8124500" y="5308061"/>
+            <a:ext cx="3214060" cy="300000"/>
+          </a:xfrm>
+          <a:prstGeom prst="rect">
+            <a:avLst/>
+          </a:prstGeom>
+          <a:noFill/>
+        </p:spPr>
+        <p:txBody>
+          <a:bodyPr wrap="square">
+            <a:spAutoFit/>
+          </a:bodyPr>
+          <a:lstStyle/>
+          <a:p>
+            <a:pPr algn="ctr"/>
+            <a:r>
+              <a:rPr sz="1300" b="1">
+                <a:solidFill>
+                  <a:srgbClr val="2D2B39"/>
+                </a:solidFill>
+                <a:latin typeface="Aptos"/>
+              </a:rPr>
+              <a:t>Looks cancelled · silent alert sent</a:t>
+            </a:r>
+          </a:p>
+        </p:txBody>
+      </p:sp>
     </p:spTree>
   </p:cSld>
   <p:clrMapOvr>

</xml_diff>